<commit_message>
Adjust invoice text position in investor deck slide
</commit_message>
<xml_diff>
--- a/docs/meridian-investor-deck.pptx
+++ b/docs/meridian-investor-deck.pptx
@@ -2420,6 +2420,58 @@
         </p:nvSpPr>
         <p:spPr>
           <a:xfrm>
+            <a:off x="640080" y="420624"/>
+            <a:ext cx="566928" cy="566928"/>
+          </a:xfrm>
+          <a:prstGeom prst="roundRect">
+            <a:avLst>
+              <a:gd name="adj" fmla="val 21800"/>
+            </a:avLst>
+          </a:prstGeom>
+          <a:solidFill>
+            <a:srgbClr val="3ECFA0"/>
+          </a:solidFill>
+          <a:ln w="12700">
+            <a:solidFill>
+              <a:srgbClr val="3ECFA0"/>
+            </a:solidFill>
+            <a:prstDash val="solid"/>
+          </a:ln>
+        </p:spPr>
+      </p:sp>
+      <p:sp>
+        <p:nvSpPr>
+          <p:cNvPr id="3" name="Shape 1"/>
+          <p:cNvSpPr/>
+          <p:nvPr/>
+        </p:nvSpPr>
+        <p:spPr>
+          <a:xfrm>
+            <a:off x="799954" y="580498"/>
+            <a:ext cx="247181" cy="247181"/>
+          </a:xfrm>
+          <a:prstGeom prst="ellipse">
+            <a:avLst/>
+          </a:prstGeom>
+          <a:solidFill>
+            <a:srgbClr val="3ECFA0"/>
+          </a:solidFill>
+          <a:ln w="28661">
+            <a:solidFill>
+              <a:srgbClr val="0B1A19"/>
+            </a:solidFill>
+            <a:prstDash val="solid"/>
+          </a:ln>
+        </p:spPr>
+      </p:sp>
+      <p:sp>
+        <p:nvSpPr>
+          <p:cNvPr id="4" name="Shape 2"/>
+          <p:cNvSpPr/>
+          <p:nvPr/>
+        </p:nvSpPr>
+        <p:spPr>
+          <a:xfrm>
             <a:off x="10040112" y="512064"/>
             <a:ext cx="1508760" cy="384048"/>
           </a:xfrm>
@@ -2441,7 +2493,7 @@
       </p:sp>
       <p:sp>
         <p:nvSpPr>
-          <p:cNvPr id="3" name="Text 1"/>
+          <p:cNvPr id="5" name="Text 3"/>
           <p:cNvSpPr txBox="1"/>
           <p:nvPr/>
         </p:nvSpPr>
@@ -2480,14 +2532,14 @@
       </p:sp>
       <p:sp>
         <p:nvSpPr>
-          <p:cNvPr id="4" name="Text 2"/>
-          <p:cNvSpPr txBox="1"/>
-          <p:nvPr/>
-        </p:nvSpPr>
-        <p:spPr>
-          <a:xfrm>
-            <a:off x="777240" y="1874520"/>
-            <a:ext cx="6583680" cy="1508760"/>
+          <p:cNvPr id="6" name="Text 4"/>
+          <p:cNvSpPr txBox="1"/>
+          <p:nvPr/>
+        </p:nvSpPr>
+        <p:spPr>
+          <a:xfrm>
+            <a:off x="640080" y="1874520"/>
+            <a:ext cx="6766560" cy="1508760"/>
           </a:xfrm>
           <a:prstGeom prst="rect">
             <a:avLst/>
@@ -2533,14 +2585,14 @@
       </p:sp>
       <p:sp>
         <p:nvSpPr>
-          <p:cNvPr id="5" name="Text 3"/>
-          <p:cNvSpPr txBox="1"/>
-          <p:nvPr/>
-        </p:nvSpPr>
-        <p:spPr>
-          <a:xfrm>
-            <a:off x="822960" y="3611880"/>
-            <a:ext cx="6309360" cy="1371600"/>
+          <p:cNvPr id="7" name="Text 5"/>
+          <p:cNvSpPr txBox="1"/>
+          <p:nvPr/>
+        </p:nvSpPr>
+        <p:spPr>
+          <a:xfrm>
+            <a:off x="640080" y="3611880"/>
+            <a:ext cx="6492240" cy="1371600"/>
           </a:xfrm>
           <a:prstGeom prst="rect">
             <a:avLst/>
@@ -2575,14 +2627,14 @@
       </p:sp>
       <p:sp>
         <p:nvSpPr>
-          <p:cNvPr id="6" name="Text 4"/>
-          <p:cNvSpPr txBox="1"/>
-          <p:nvPr/>
-        </p:nvSpPr>
-        <p:spPr>
-          <a:xfrm>
-            <a:off x="822960" y="5074920"/>
-            <a:ext cx="6309360" cy="320040"/>
+          <p:cNvPr id="8" name="Text 6"/>
+          <p:cNvSpPr txBox="1"/>
+          <p:nvPr/>
+        </p:nvSpPr>
+        <p:spPr>
+          <a:xfrm>
+            <a:off x="640080" y="5074920"/>
+            <a:ext cx="6492240" cy="320040"/>
           </a:xfrm>
           <a:prstGeom prst="rect">
             <a:avLst/>
@@ -2614,7 +2666,7 @@
       </p:sp>
       <p:sp>
         <p:nvSpPr>
-          <p:cNvPr id="7" name="Shape 5"/>
+          <p:cNvPr id="9" name="Shape 7"/>
           <p:cNvSpPr/>
           <p:nvPr/>
         </p:nvSpPr>
@@ -2641,7 +2693,7 @@
       </p:sp>
       <p:sp>
         <p:nvSpPr>
-          <p:cNvPr id="8" name="Text 6"/>
+          <p:cNvPr id="10" name="Text 8"/>
           <p:cNvSpPr txBox="1"/>
           <p:nvPr/>
         </p:nvSpPr>
@@ -2680,7 +2732,7 @@
       </p:sp>
       <p:sp>
         <p:nvSpPr>
-          <p:cNvPr id="9" name="Text 7"/>
+          <p:cNvPr id="11" name="Text 9"/>
           <p:cNvSpPr txBox="1"/>
           <p:nvPr/>
         </p:nvSpPr>
@@ -2719,7 +2771,7 @@
       </p:sp>
       <p:sp>
         <p:nvSpPr>
-          <p:cNvPr id="10" name="Text 8"/>
+          <p:cNvPr id="12" name="Text 10"/>
           <p:cNvSpPr txBox="1"/>
           <p:nvPr/>
         </p:nvSpPr>
@@ -2758,7 +2810,7 @@
       </p:sp>
       <p:sp>
         <p:nvSpPr>
-          <p:cNvPr id="11" name="Shape 9"/>
+          <p:cNvPr id="13" name="Shape 11"/>
           <p:cNvSpPr/>
           <p:nvPr/>
         </p:nvSpPr>
@@ -2778,7 +2830,7 @@
       </p:sp>
       <p:sp>
         <p:nvSpPr>
-          <p:cNvPr id="12" name="Text 10"/>
+          <p:cNvPr id="14" name="Text 12"/>
           <p:cNvSpPr txBox="1"/>
           <p:nvPr/>
         </p:nvSpPr>
@@ -2860,7 +2912,7 @@
       </p:sp>
       <p:sp>
         <p:nvSpPr>
-          <p:cNvPr id="13" name="Shape 11"/>
+          <p:cNvPr id="15" name="Shape 13"/>
           <p:cNvSpPr/>
           <p:nvPr/>
         </p:nvSpPr>
@@ -2887,7 +2939,7 @@
       </p:sp>
       <p:sp>
         <p:nvSpPr>
-          <p:cNvPr id="14" name="Text 12"/>
+          <p:cNvPr id="16" name="Text 14"/>
           <p:cNvSpPr txBox="1"/>
           <p:nvPr/>
         </p:nvSpPr>
@@ -2926,7 +2978,7 @@
       </p:sp>
       <p:sp>
         <p:nvSpPr>
-          <p:cNvPr id="15" name="Text 13"/>
+          <p:cNvPr id="17" name="Text 15"/>
           <p:cNvSpPr txBox="1"/>
           <p:nvPr/>
         </p:nvSpPr>
@@ -2965,7 +3017,7 @@
       </p:sp>
       <p:sp>
         <p:nvSpPr>
-          <p:cNvPr id="16" name="Text 14"/>
+          <p:cNvPr id="18" name="Text 16"/>
           <p:cNvSpPr txBox="1"/>
           <p:nvPr/>
         </p:nvSpPr>
@@ -3004,7 +3056,7 @@
       </p:sp>
       <p:sp>
         <p:nvSpPr>
-          <p:cNvPr id="17" name="Text 15"/>
+          <p:cNvPr id="19" name="Text 17"/>
           <p:cNvSpPr txBox="1"/>
           <p:nvPr/>
         </p:nvSpPr>
@@ -3043,13 +3095,13 @@
       </p:sp>
       <p:sp>
         <p:nvSpPr>
-          <p:cNvPr id="18" name="Text 16"/>
-          <p:cNvSpPr txBox="1"/>
-          <p:nvPr/>
-        </p:nvSpPr>
-        <p:spPr>
-          <a:xfrm>
-            <a:off x="822960" y="6382512"/>
+          <p:cNvPr id="20" name="Text 18"/>
+          <p:cNvSpPr txBox="1"/>
+          <p:nvPr/>
+        </p:nvSpPr>
+        <p:spPr>
+          <a:xfrm>
+            <a:off x="640080" y="6355080"/>
             <a:ext cx="7863840" cy="292608"/>
           </a:xfrm>
           <a:prstGeom prst="rect">
@@ -3082,13 +3134,13 @@
       </p:sp>
       <p:sp>
         <p:nvSpPr>
-          <p:cNvPr id="19" name="Text 17"/>
-          <p:cNvSpPr txBox="1"/>
-          <p:nvPr/>
-        </p:nvSpPr>
-        <p:spPr>
-          <a:xfrm>
-            <a:off x="9537192" y="6345936"/>
+          <p:cNvPr id="21" name="Text 19"/>
+          <p:cNvSpPr txBox="1"/>
+          <p:nvPr/>
+        </p:nvSpPr>
+        <p:spPr>
+          <a:xfrm>
+            <a:off x="9537192" y="6327648"/>
             <a:ext cx="2011680" cy="347472"/>
           </a:xfrm>
           <a:prstGeom prst="rect">
@@ -3248,96 +3300,148 @@
       </p:sp>
       <p:sp>
         <p:nvSpPr>
-          <p:cNvPr id="4" name="Text 2"/>
-          <p:cNvSpPr txBox="1"/>
-          <p:nvPr/>
-        </p:nvSpPr>
-        <p:spPr>
-          <a:xfrm>
-            <a:off x="640080" y="6510528"/>
-            <a:ext cx="3657600" cy="237744"/>
-          </a:xfrm>
-          <a:prstGeom prst="rect">
-            <a:avLst/>
-          </a:prstGeom>
-          <a:noFill/>
-          <a:ln/>
-        </p:spPr>
-        <p:txBody>
-          <a:bodyPr wrap="square" lIns="0" tIns="0" rIns="0" bIns="0" rtlCol="0" anchor="ctr"/>
-          <a:lstStyle/>
-          <a:p>
-            <a:pPr algn="l" indent="0" marL="0">
-              <a:buNone/>
-            </a:pPr>
-            <a:r>
-              <a:rPr lang="en-US" sz="800" b="1" spc="4000" kern="0" dirty="0">
-                <a:solidFill>
-                  <a:srgbClr val="4F6B66"/>
-                </a:solidFill>
-                <a:latin typeface="Calibri" pitchFamily="34" charset="0"/>
-                <a:ea typeface="Calibri" pitchFamily="34" charset="-122"/>
-                <a:cs typeface="Calibri" pitchFamily="34" charset="-120"/>
-              </a:rPr>
-              <a:t>MERIDIAN · APPIFY SOFTWARES</a:t>
-            </a:r>
-            <a:endParaRPr lang="en-US" sz="800" dirty="0"/>
-          </a:p>
-        </p:txBody>
-      </p:sp>
-      <p:sp>
-        <p:nvSpPr>
-          <p:cNvPr id="5" name="Text 3"/>
-          <p:cNvSpPr txBox="1"/>
-          <p:nvPr/>
-        </p:nvSpPr>
-        <p:spPr>
-          <a:xfrm>
-            <a:off x="7434072" y="6510528"/>
-            <a:ext cx="4114800" cy="237744"/>
-          </a:xfrm>
-          <a:prstGeom prst="rect">
-            <a:avLst/>
-          </a:prstGeom>
-          <a:noFill/>
-          <a:ln/>
-        </p:spPr>
-        <p:txBody>
-          <a:bodyPr wrap="square" lIns="0" tIns="0" rIns="0" bIns="0" rtlCol="0" anchor="ctr"/>
-          <a:lstStyle/>
-          <a:p>
-            <a:pPr algn="r" indent="0" marL="0">
-              <a:buNone/>
-            </a:pPr>
-            <a:r>
-              <a:rPr lang="en-US" sz="800" b="1" spc="4000" kern="0" dirty="0">
-                <a:solidFill>
-                  <a:srgbClr val="4F6B66"/>
-                </a:solidFill>
-                <a:latin typeface="Calibri" pitchFamily="34" charset="0"/>
-                <a:ea typeface="Calibri" pitchFamily="34" charset="-122"/>
-                <a:cs typeface="Calibri" pitchFamily="34" charset="-120"/>
-              </a:rPr>
-              <a:t>PROJECTIONS ILLUSTRATIVE · 10 / 12</a:t>
-            </a:r>
-            <a:endParaRPr lang="en-US" sz="800" dirty="0"/>
-          </a:p>
-        </p:txBody>
-      </p:sp>
-      <p:sp>
-        <p:nvSpPr>
-          <p:cNvPr id="6" name="Shape 4"/>
+          <p:cNvPr id="4" name="Shape 2"/>
           <p:cNvSpPr/>
           <p:nvPr/>
         </p:nvSpPr>
         <p:spPr>
           <a:xfrm>
-            <a:off x="640080" y="2286000"/>
-            <a:ext cx="3456432" cy="2834640"/>
+            <a:off x="640080" y="6382512"/>
+            <a:ext cx="274320" cy="274320"/>
           </a:xfrm>
           <a:prstGeom prst="roundRect">
             <a:avLst>
-              <a:gd name="adj" fmla="val 3871"/>
+              <a:gd name="adj" fmla="val 21800"/>
+            </a:avLst>
+          </a:prstGeom>
+          <a:solidFill>
+            <a:srgbClr val="3ECFA0"/>
+          </a:solidFill>
+          <a:ln w="12700">
+            <a:solidFill>
+              <a:srgbClr val="3ECFA0"/>
+            </a:solidFill>
+            <a:prstDash val="solid"/>
+          </a:ln>
+        </p:spPr>
+      </p:sp>
+      <p:sp>
+        <p:nvSpPr>
+          <p:cNvPr id="5" name="Shape 3"/>
+          <p:cNvSpPr/>
+          <p:nvPr/>
+        </p:nvSpPr>
+        <p:spPr>
+          <a:xfrm>
+            <a:off x="717438" y="6459870"/>
+            <a:ext cx="119604" cy="119604"/>
+          </a:xfrm>
+          <a:prstGeom prst="ellipse">
+            <a:avLst/>
+          </a:prstGeom>
+          <a:solidFill>
+            <a:srgbClr val="3ECFA0"/>
+          </a:solidFill>
+          <a:ln w="13868">
+            <a:solidFill>
+              <a:srgbClr val="0B1A19"/>
+            </a:solidFill>
+            <a:prstDash val="solid"/>
+          </a:ln>
+        </p:spPr>
+      </p:sp>
+      <p:sp>
+        <p:nvSpPr>
+          <p:cNvPr id="6" name="Text 4"/>
+          <p:cNvSpPr txBox="1"/>
+          <p:nvPr/>
+        </p:nvSpPr>
+        <p:spPr>
+          <a:xfrm>
+            <a:off x="1005840" y="6400800"/>
+            <a:ext cx="3291840" cy="237744"/>
+          </a:xfrm>
+          <a:prstGeom prst="rect">
+            <a:avLst/>
+          </a:prstGeom>
+          <a:noFill/>
+          <a:ln/>
+        </p:spPr>
+        <p:txBody>
+          <a:bodyPr wrap="square" lIns="0" tIns="0" rIns="0" bIns="0" rtlCol="0" anchor="ctr"/>
+          <a:lstStyle/>
+          <a:p>
+            <a:pPr algn="l" indent="0" marL="0">
+              <a:buNone/>
+            </a:pPr>
+            <a:r>
+              <a:rPr lang="en-US" sz="800" b="1" spc="4000" kern="0" dirty="0">
+                <a:solidFill>
+                  <a:srgbClr val="4F6B66"/>
+                </a:solidFill>
+                <a:latin typeface="Calibri" pitchFamily="34" charset="0"/>
+                <a:ea typeface="Calibri" pitchFamily="34" charset="-122"/>
+                <a:cs typeface="Calibri" pitchFamily="34" charset="-120"/>
+              </a:rPr>
+              <a:t>MERIDIAN · APPIFY SOFTWARES</a:t>
+            </a:r>
+            <a:endParaRPr lang="en-US" sz="800" dirty="0"/>
+          </a:p>
+        </p:txBody>
+      </p:sp>
+      <p:sp>
+        <p:nvSpPr>
+          <p:cNvPr id="7" name="Text 5"/>
+          <p:cNvSpPr txBox="1"/>
+          <p:nvPr/>
+        </p:nvSpPr>
+        <p:spPr>
+          <a:xfrm>
+            <a:off x="7434072" y="6400800"/>
+            <a:ext cx="4114800" cy="237744"/>
+          </a:xfrm>
+          <a:prstGeom prst="rect">
+            <a:avLst/>
+          </a:prstGeom>
+          <a:noFill/>
+          <a:ln/>
+        </p:spPr>
+        <p:txBody>
+          <a:bodyPr wrap="square" lIns="0" tIns="0" rIns="0" bIns="0" rtlCol="0" anchor="ctr"/>
+          <a:lstStyle/>
+          <a:p>
+            <a:pPr algn="r" indent="0" marL="0">
+              <a:buNone/>
+            </a:pPr>
+            <a:r>
+              <a:rPr lang="en-US" sz="800" b="1" spc="4000" kern="0" dirty="0">
+                <a:solidFill>
+                  <a:srgbClr val="4F6B66"/>
+                </a:solidFill>
+                <a:latin typeface="Calibri" pitchFamily="34" charset="0"/>
+                <a:ea typeface="Calibri" pitchFamily="34" charset="-122"/>
+                <a:cs typeface="Calibri" pitchFamily="34" charset="-120"/>
+              </a:rPr>
+              <a:t>PROJECTIONS ILLUSTRATIVE · 10 / 12</a:t>
+            </a:r>
+            <a:endParaRPr lang="en-US" sz="800" dirty="0"/>
+          </a:p>
+        </p:txBody>
+      </p:sp>
+      <p:sp>
+        <p:nvSpPr>
+          <p:cNvPr id="8" name="Shape 6"/>
+          <p:cNvSpPr/>
+          <p:nvPr/>
+        </p:nvSpPr>
+        <p:spPr>
+          <a:xfrm>
+            <a:off x="640080" y="2286000"/>
+            <a:ext cx="3456432" cy="2999232"/>
+          </a:xfrm>
+          <a:prstGeom prst="roundRect">
+            <a:avLst>
+              <a:gd name="adj" fmla="val 3659"/>
             </a:avLst>
           </a:prstGeom>
           <a:solidFill>
@@ -3353,7 +3457,7 @@
       </p:sp>
       <p:sp>
         <p:nvSpPr>
-          <p:cNvPr id="7" name="Shape 5"/>
+          <p:cNvPr id="9" name="Shape 7"/>
           <p:cNvSpPr/>
           <p:nvPr/>
         </p:nvSpPr>
@@ -3373,7 +3477,7 @@
       </p:sp>
       <p:sp>
         <p:nvSpPr>
-          <p:cNvPr id="8" name="Text 6"/>
+          <p:cNvPr id="10" name="Text 8"/>
           <p:cNvSpPr txBox="1"/>
           <p:nvPr/>
         </p:nvSpPr>
@@ -3412,7 +3516,7 @@
       </p:sp>
       <p:sp>
         <p:nvSpPr>
-          <p:cNvPr id="9" name="Text 7"/>
+          <p:cNvPr id="11" name="Text 9"/>
           <p:cNvSpPr txBox="1"/>
           <p:nvPr/>
         </p:nvSpPr>
@@ -3451,7 +3555,7 @@
       </p:sp>
       <p:sp>
         <p:nvSpPr>
-          <p:cNvPr id="10" name="Text 8"/>
+          <p:cNvPr id="12" name="Text 10"/>
           <p:cNvSpPr txBox="1"/>
           <p:nvPr/>
         </p:nvSpPr>
@@ -3490,7 +3594,7 @@
       </p:sp>
       <p:sp>
         <p:nvSpPr>
-          <p:cNvPr id="11" name="Text 9"/>
+          <p:cNvPr id="13" name="Text 11"/>
           <p:cNvSpPr txBox="1"/>
           <p:nvPr/>
         </p:nvSpPr>
@@ -3532,18 +3636,18 @@
       </p:sp>
       <p:sp>
         <p:nvSpPr>
-          <p:cNvPr id="12" name="Shape 10"/>
+          <p:cNvPr id="14" name="Shape 12"/>
           <p:cNvSpPr/>
           <p:nvPr/>
         </p:nvSpPr>
         <p:spPr>
           <a:xfrm>
             <a:off x="4361688" y="2286000"/>
-            <a:ext cx="3456432" cy="2834640"/>
+            <a:ext cx="3456432" cy="2999232"/>
           </a:xfrm>
           <a:prstGeom prst="roundRect">
             <a:avLst>
-              <a:gd name="adj" fmla="val 3871"/>
+              <a:gd name="adj" fmla="val 3659"/>
             </a:avLst>
           </a:prstGeom>
           <a:solidFill>
@@ -3559,7 +3663,7 @@
       </p:sp>
       <p:sp>
         <p:nvSpPr>
-          <p:cNvPr id="13" name="Shape 11"/>
+          <p:cNvPr id="15" name="Shape 13"/>
           <p:cNvSpPr/>
           <p:nvPr/>
         </p:nvSpPr>
@@ -3579,7 +3683,7 @@
       </p:sp>
       <p:sp>
         <p:nvSpPr>
-          <p:cNvPr id="14" name="Text 12"/>
+          <p:cNvPr id="16" name="Text 14"/>
           <p:cNvSpPr txBox="1"/>
           <p:nvPr/>
         </p:nvSpPr>
@@ -3618,7 +3722,7 @@
       </p:sp>
       <p:sp>
         <p:nvSpPr>
-          <p:cNvPr id="15" name="Text 13"/>
+          <p:cNvPr id="17" name="Text 15"/>
           <p:cNvSpPr txBox="1"/>
           <p:nvPr/>
         </p:nvSpPr>
@@ -3657,7 +3761,7 @@
       </p:sp>
       <p:sp>
         <p:nvSpPr>
-          <p:cNvPr id="16" name="Text 14"/>
+          <p:cNvPr id="18" name="Text 16"/>
           <p:cNvSpPr txBox="1"/>
           <p:nvPr/>
         </p:nvSpPr>
@@ -3696,7 +3800,7 @@
       </p:sp>
       <p:sp>
         <p:nvSpPr>
-          <p:cNvPr id="17" name="Text 15"/>
+          <p:cNvPr id="19" name="Text 17"/>
           <p:cNvSpPr txBox="1"/>
           <p:nvPr/>
         </p:nvSpPr>
@@ -3738,18 +3842,18 @@
       </p:sp>
       <p:sp>
         <p:nvSpPr>
-          <p:cNvPr id="18" name="Shape 16"/>
+          <p:cNvPr id="20" name="Shape 18"/>
           <p:cNvSpPr/>
           <p:nvPr/>
         </p:nvSpPr>
         <p:spPr>
           <a:xfrm>
             <a:off x="8083296" y="2286000"/>
-            <a:ext cx="3456432" cy="2834640"/>
+            <a:ext cx="3456432" cy="2999232"/>
           </a:xfrm>
           <a:prstGeom prst="roundRect">
             <a:avLst>
-              <a:gd name="adj" fmla="val 3871"/>
+              <a:gd name="adj" fmla="val 3659"/>
             </a:avLst>
           </a:prstGeom>
           <a:solidFill>
@@ -3765,7 +3869,7 @@
       </p:sp>
       <p:sp>
         <p:nvSpPr>
-          <p:cNvPr id="19" name="Shape 17"/>
+          <p:cNvPr id="21" name="Shape 19"/>
           <p:cNvSpPr/>
           <p:nvPr/>
         </p:nvSpPr>
@@ -3785,7 +3889,7 @@
       </p:sp>
       <p:pic>
         <p:nvPicPr>
-          <p:cNvPr id="20" name="Image 0" descr="preencoded.png">    </p:cNvPr>
+          <p:cNvPr id="22" name="Image 0" descr="preencoded.png">    </p:cNvPr>
           <p:cNvPicPr>
             <a:picLocks noChangeAspect="1"/>
           </p:cNvPicPr>
@@ -3809,7 +3913,7 @@
       </p:pic>
       <p:sp>
         <p:nvSpPr>
-          <p:cNvPr id="21" name="Text 18"/>
+          <p:cNvPr id="23" name="Text 20"/>
           <p:cNvSpPr txBox="1"/>
           <p:nvPr/>
         </p:nvSpPr>
@@ -3848,7 +3952,7 @@
       </p:sp>
       <p:sp>
         <p:nvSpPr>
-          <p:cNvPr id="22" name="Text 19"/>
+          <p:cNvPr id="24" name="Text 21"/>
           <p:cNvSpPr txBox="1"/>
           <p:nvPr/>
         </p:nvSpPr>
@@ -3887,7 +3991,7 @@
       </p:sp>
       <p:sp>
         <p:nvSpPr>
-          <p:cNvPr id="23" name="Text 20"/>
+          <p:cNvPr id="25" name="Text 22"/>
           <p:cNvSpPr txBox="1"/>
           <p:nvPr/>
         </p:nvSpPr>
@@ -3929,13 +4033,13 @@
       </p:sp>
       <p:sp>
         <p:nvSpPr>
-          <p:cNvPr id="24" name="Text 21"/>
-          <p:cNvSpPr txBox="1"/>
-          <p:nvPr/>
-        </p:nvSpPr>
-        <p:spPr>
-          <a:xfrm>
-            <a:off x="640080" y="5486400"/>
+          <p:cNvPr id="26" name="Text 23"/>
+          <p:cNvSpPr txBox="1"/>
+          <p:nvPr/>
+        </p:nvSpPr>
+        <p:spPr>
+          <a:xfrm>
+            <a:off x="640080" y="5577840"/>
             <a:ext cx="10908792" cy="365760"/>
           </a:xfrm>
           <a:prstGeom prst="rect">
@@ -4115,14 +4219,66 @@
       </p:sp>
       <p:sp>
         <p:nvSpPr>
-          <p:cNvPr id="4" name="Text 2"/>
-          <p:cNvSpPr txBox="1"/>
-          <p:nvPr/>
-        </p:nvSpPr>
-        <p:spPr>
-          <a:xfrm>
-            <a:off x="640080" y="6510528"/>
-            <a:ext cx="3657600" cy="237744"/>
+          <p:cNvPr id="4" name="Shape 2"/>
+          <p:cNvSpPr/>
+          <p:nvPr/>
+        </p:nvSpPr>
+        <p:spPr>
+          <a:xfrm>
+            <a:off x="640080" y="6382512"/>
+            <a:ext cx="274320" cy="274320"/>
+          </a:xfrm>
+          <a:prstGeom prst="roundRect">
+            <a:avLst>
+              <a:gd name="adj" fmla="val 21800"/>
+            </a:avLst>
+          </a:prstGeom>
+          <a:solidFill>
+            <a:srgbClr val="3ECFA0"/>
+          </a:solidFill>
+          <a:ln w="12700">
+            <a:solidFill>
+              <a:srgbClr val="3ECFA0"/>
+            </a:solidFill>
+            <a:prstDash val="solid"/>
+          </a:ln>
+        </p:spPr>
+      </p:sp>
+      <p:sp>
+        <p:nvSpPr>
+          <p:cNvPr id="5" name="Shape 3"/>
+          <p:cNvSpPr/>
+          <p:nvPr/>
+        </p:nvSpPr>
+        <p:spPr>
+          <a:xfrm>
+            <a:off x="717438" y="6459870"/>
+            <a:ext cx="119604" cy="119604"/>
+          </a:xfrm>
+          <a:prstGeom prst="ellipse">
+            <a:avLst/>
+          </a:prstGeom>
+          <a:solidFill>
+            <a:srgbClr val="3ECFA0"/>
+          </a:solidFill>
+          <a:ln w="13868">
+            <a:solidFill>
+              <a:srgbClr val="0B1A19"/>
+            </a:solidFill>
+            <a:prstDash val="solid"/>
+          </a:ln>
+        </p:spPr>
+      </p:sp>
+      <p:sp>
+        <p:nvSpPr>
+          <p:cNvPr id="6" name="Text 4"/>
+          <p:cNvSpPr txBox="1"/>
+          <p:nvPr/>
+        </p:nvSpPr>
+        <p:spPr>
+          <a:xfrm>
+            <a:off x="1005840" y="6400800"/>
+            <a:ext cx="3291840" cy="237744"/>
           </a:xfrm>
           <a:prstGeom prst="rect">
             <a:avLst/>
@@ -4154,13 +4310,13 @@
       </p:sp>
       <p:sp>
         <p:nvSpPr>
-          <p:cNvPr id="5" name="Text 3"/>
-          <p:cNvSpPr txBox="1"/>
-          <p:nvPr/>
-        </p:nvSpPr>
-        <p:spPr>
-          <a:xfrm>
-            <a:off x="7434072" y="6510528"/>
+          <p:cNvPr id="7" name="Text 5"/>
+          <p:cNvSpPr txBox="1"/>
+          <p:nvPr/>
+        </p:nvSpPr>
+        <p:spPr>
+          <a:xfrm>
+            <a:off x="7434072" y="6400800"/>
             <a:ext cx="4114800" cy="237744"/>
           </a:xfrm>
           <a:prstGeom prst="rect">
@@ -4193,7 +4349,7 @@
       </p:sp>
       <p:sp>
         <p:nvSpPr>
-          <p:cNvPr id="6" name="Text 4"/>
+          <p:cNvPr id="8" name="Text 6"/>
           <p:cNvSpPr txBox="1"/>
           <p:nvPr/>
         </p:nvSpPr>
@@ -4232,7 +4388,7 @@
       </p:sp>
       <p:graphicFrame>
         <p:nvGraphicFramePr>
-          <p:cNvPr id="7" name="Chart 0" descr=""/>
+          <p:cNvPr id="9" name="Chart 0" descr=""/>
           <p:cNvGraphicFramePr/>
           <p:nvPr/>
         </p:nvGraphicFramePr>
@@ -4248,7 +4404,7 @@
       </p:graphicFrame>
       <p:sp>
         <p:nvSpPr>
-          <p:cNvPr id="8" name="Shape 5"/>
+          <p:cNvPr id="10" name="Shape 7"/>
           <p:cNvSpPr/>
           <p:nvPr/>
         </p:nvSpPr>
@@ -4275,14 +4431,14 @@
       </p:sp>
       <p:sp>
         <p:nvSpPr>
-          <p:cNvPr id="9" name="Text 6"/>
+          <p:cNvPr id="11" name="Text 8"/>
           <p:cNvSpPr txBox="1"/>
           <p:nvPr/>
         </p:nvSpPr>
         <p:spPr>
           <a:xfrm>
             <a:off x="7635240" y="2651760"/>
-            <a:ext cx="3657600" cy="256032"/>
+            <a:ext cx="3593592" cy="256032"/>
           </a:xfrm>
           <a:prstGeom prst="rect">
             <a:avLst/>
@@ -4314,14 +4470,14 @@
       </p:sp>
       <p:sp>
         <p:nvSpPr>
-          <p:cNvPr id="10" name="Text 7"/>
+          <p:cNvPr id="12" name="Text 9"/>
           <p:cNvSpPr txBox="1"/>
           <p:nvPr/>
         </p:nvSpPr>
         <p:spPr>
           <a:xfrm>
             <a:off x="7635240" y="2999232"/>
-            <a:ext cx="3611880" cy="868680"/>
+            <a:ext cx="3593592" cy="868680"/>
           </a:xfrm>
           <a:prstGeom prst="rect">
             <a:avLst/>
@@ -4356,14 +4512,14 @@
       </p:sp>
       <p:sp>
         <p:nvSpPr>
-          <p:cNvPr id="11" name="Text 8"/>
-          <p:cNvSpPr txBox="1"/>
-          <p:nvPr/>
-        </p:nvSpPr>
-        <p:spPr>
-          <a:xfrm>
-            <a:off x="7635240" y="3977640"/>
-            <a:ext cx="3611880" cy="457200"/>
+          <p:cNvPr id="13" name="Text 10"/>
+          <p:cNvSpPr txBox="1"/>
+          <p:nvPr/>
+        </p:nvSpPr>
+        <p:spPr>
+          <a:xfrm>
+            <a:off x="7635240" y="3931920"/>
+            <a:ext cx="3593592" cy="411480"/>
           </a:xfrm>
           <a:prstGeom prst="rect">
             <a:avLst/>
@@ -4398,7 +4554,7 @@
       </p:sp>
       <p:sp>
         <p:nvSpPr>
-          <p:cNvPr id="12" name="Shape 9"/>
+          <p:cNvPr id="14" name="Shape 11"/>
           <p:cNvSpPr/>
           <p:nvPr/>
         </p:nvSpPr>
@@ -4420,14 +4576,14 @@
       </p:sp>
       <p:sp>
         <p:nvSpPr>
-          <p:cNvPr id="13" name="Text 10"/>
-          <p:cNvSpPr txBox="1"/>
-          <p:nvPr/>
-        </p:nvSpPr>
-        <p:spPr>
-          <a:xfrm>
-            <a:off x="7635240" y="5074920"/>
-            <a:ext cx="3657600" cy="822960"/>
+          <p:cNvPr id="15" name="Text 12"/>
+          <p:cNvSpPr txBox="1"/>
+          <p:nvPr/>
+        </p:nvSpPr>
+        <p:spPr>
+          <a:xfrm>
+            <a:off x="7635240" y="5056632"/>
+            <a:ext cx="3593592" cy="822960"/>
           </a:xfrm>
           <a:prstGeom prst="rect">
             <a:avLst/>
@@ -4629,140 +4785,133 @@
       </p:sp>
       <p:sp>
         <p:nvSpPr>
-          <p:cNvPr id="4" name="Text 2"/>
-          <p:cNvSpPr txBox="1"/>
-          <p:nvPr/>
-        </p:nvSpPr>
-        <p:spPr>
-          <a:xfrm>
-            <a:off x="640080" y="6510528"/>
-            <a:ext cx="3657600" cy="237744"/>
-          </a:xfrm>
-          <a:prstGeom prst="rect">
-            <a:avLst/>
-          </a:prstGeom>
-          <a:noFill/>
-          <a:ln/>
-        </p:spPr>
-        <p:txBody>
-          <a:bodyPr wrap="square" lIns="0" tIns="0" rIns="0" bIns="0" rtlCol="0" anchor="ctr"/>
-          <a:lstStyle/>
-          <a:p>
-            <a:pPr algn="l" indent="0" marL="0">
-              <a:buNone/>
-            </a:pPr>
-            <a:r>
-              <a:rPr lang="en-US" sz="800" b="1" spc="4000" kern="0" dirty="0">
-                <a:solidFill>
-                  <a:srgbClr val="9FB8B2"/>
-                </a:solidFill>
-                <a:latin typeface="Calibri" pitchFamily="34" charset="0"/>
-                <a:ea typeface="Calibri" pitchFamily="34" charset="-122"/>
-                <a:cs typeface="Calibri" pitchFamily="34" charset="-120"/>
-              </a:rPr>
-              <a:t>MERIDIAN · APPIFY SOFTWARES</a:t>
-            </a:r>
-            <a:endParaRPr lang="en-US" sz="800" dirty="0"/>
-          </a:p>
-        </p:txBody>
-      </p:sp>
-      <p:sp>
-        <p:nvSpPr>
-          <p:cNvPr id="5" name="Text 3"/>
-          <p:cNvSpPr txBox="1"/>
-          <p:nvPr/>
-        </p:nvSpPr>
-        <p:spPr>
-          <a:xfrm>
-            <a:off x="7434072" y="6510528"/>
-            <a:ext cx="4114800" cy="237744"/>
-          </a:xfrm>
-          <a:prstGeom prst="rect">
-            <a:avLst/>
-          </a:prstGeom>
-          <a:noFill/>
-          <a:ln/>
-        </p:spPr>
-        <p:txBody>
-          <a:bodyPr wrap="square" lIns="0" tIns="0" rIns="0" bIns="0" rtlCol="0" anchor="ctr"/>
-          <a:lstStyle/>
-          <a:p>
-            <a:pPr algn="r" indent="0" marL="0">
-              <a:buNone/>
-            </a:pPr>
-            <a:r>
-              <a:rPr lang="en-US" sz="800" b="1" spc="4000" kern="0" dirty="0">
-                <a:solidFill>
-                  <a:srgbClr val="9FB8B2"/>
-                </a:solidFill>
-                <a:latin typeface="Calibri" pitchFamily="34" charset="0"/>
-                <a:ea typeface="Calibri" pitchFamily="34" charset="-122"/>
-                <a:cs typeface="Calibri" pitchFamily="34" charset="-120"/>
-              </a:rPr>
-              <a:t>PROJECTIONS ILLUSTRATIVE · 12 / 12</a:t>
-            </a:r>
-            <a:endParaRPr lang="en-US" sz="800" dirty="0"/>
-          </a:p>
-        </p:txBody>
-      </p:sp>
-      <p:sp>
-        <p:nvSpPr>
-          <p:cNvPr id="6" name="Text 4"/>
-          <p:cNvSpPr txBox="1"/>
-          <p:nvPr/>
-        </p:nvSpPr>
-        <p:spPr>
-          <a:xfrm>
-            <a:off x="640080" y="2176272"/>
-            <a:ext cx="4572000" cy="256032"/>
-          </a:xfrm>
-          <a:prstGeom prst="rect">
-            <a:avLst/>
-          </a:prstGeom>
-          <a:noFill/>
-          <a:ln/>
-        </p:spPr>
-        <p:txBody>
-          <a:bodyPr wrap="square" lIns="0" tIns="0" rIns="0" bIns="0" rtlCol="0" anchor="ctr"/>
-          <a:lstStyle/>
-          <a:p>
-            <a:pPr algn="l" indent="0" marL="0">
-              <a:buNone/>
-            </a:pPr>
-            <a:r>
-              <a:rPr lang="en-US" sz="1000" b="1" spc="6000" kern="0" dirty="0">
-                <a:solidFill>
-                  <a:srgbClr val="9FB8B2"/>
-                </a:solidFill>
-                <a:latin typeface="Calibri" pitchFamily="34" charset="0"/>
-                <a:ea typeface="Calibri" pitchFamily="34" charset="-122"/>
-                <a:cs typeface="Calibri" pitchFamily="34" charset="-120"/>
-              </a:rPr>
-              <a:t>USE OF FUNDS</a:t>
-            </a:r>
-            <a:endParaRPr lang="en-US" sz="1000" dirty="0"/>
-          </a:p>
-        </p:txBody>
-      </p:sp>
-      <p:sp>
-        <p:nvSpPr>
-          <p:cNvPr id="7" name="Shape 5"/>
+          <p:cNvPr id="4" name="Shape 2"/>
           <p:cNvSpPr/>
           <p:nvPr/>
         </p:nvSpPr>
         <p:spPr>
           <a:xfrm>
-            <a:off x="640080" y="2834640"/>
-            <a:ext cx="4837176" cy="548640"/>
-          </a:xfrm>
-          <a:prstGeom prst="rect">
-            <a:avLst/>
+            <a:off x="640080" y="6382512"/>
+            <a:ext cx="274320" cy="274320"/>
+          </a:xfrm>
+          <a:prstGeom prst="roundRect">
+            <a:avLst>
+              <a:gd name="adj" fmla="val 21800"/>
+            </a:avLst>
           </a:prstGeom>
           <a:solidFill>
             <a:srgbClr val="3ECFA0"/>
           </a:solidFill>
-          <a:ln/>
-        </p:spPr>
+          <a:ln w="12700">
+            <a:solidFill>
+              <a:srgbClr val="3ECFA0"/>
+            </a:solidFill>
+            <a:prstDash val="solid"/>
+          </a:ln>
+        </p:spPr>
+      </p:sp>
+      <p:sp>
+        <p:nvSpPr>
+          <p:cNvPr id="5" name="Shape 3"/>
+          <p:cNvSpPr/>
+          <p:nvPr/>
+        </p:nvSpPr>
+        <p:spPr>
+          <a:xfrm>
+            <a:off x="717438" y="6459870"/>
+            <a:ext cx="119604" cy="119604"/>
+          </a:xfrm>
+          <a:prstGeom prst="ellipse">
+            <a:avLst/>
+          </a:prstGeom>
+          <a:solidFill>
+            <a:srgbClr val="3ECFA0"/>
+          </a:solidFill>
+          <a:ln w="13868">
+            <a:solidFill>
+              <a:srgbClr val="0B1A19"/>
+            </a:solidFill>
+            <a:prstDash val="solid"/>
+          </a:ln>
+        </p:spPr>
+      </p:sp>
+      <p:sp>
+        <p:nvSpPr>
+          <p:cNvPr id="6" name="Text 4"/>
+          <p:cNvSpPr txBox="1"/>
+          <p:nvPr/>
+        </p:nvSpPr>
+        <p:spPr>
+          <a:xfrm>
+            <a:off x="1005840" y="6400800"/>
+            <a:ext cx="3291840" cy="237744"/>
+          </a:xfrm>
+          <a:prstGeom prst="rect">
+            <a:avLst/>
+          </a:prstGeom>
+          <a:noFill/>
+          <a:ln/>
+        </p:spPr>
+        <p:txBody>
+          <a:bodyPr wrap="square" lIns="0" tIns="0" rIns="0" bIns="0" rtlCol="0" anchor="ctr"/>
+          <a:lstStyle/>
+          <a:p>
+            <a:pPr algn="l" indent="0" marL="0">
+              <a:buNone/>
+            </a:pPr>
+            <a:r>
+              <a:rPr lang="en-US" sz="800" b="1" spc="4000" kern="0" dirty="0">
+                <a:solidFill>
+                  <a:srgbClr val="9FB8B2"/>
+                </a:solidFill>
+                <a:latin typeface="Calibri" pitchFamily="34" charset="0"/>
+                <a:ea typeface="Calibri" pitchFamily="34" charset="-122"/>
+                <a:cs typeface="Calibri" pitchFamily="34" charset="-120"/>
+              </a:rPr>
+              <a:t>MERIDIAN · APPIFY SOFTWARES</a:t>
+            </a:r>
+            <a:endParaRPr lang="en-US" sz="800" dirty="0"/>
+          </a:p>
+        </p:txBody>
+      </p:sp>
+      <p:sp>
+        <p:nvSpPr>
+          <p:cNvPr id="7" name="Text 5"/>
+          <p:cNvSpPr txBox="1"/>
+          <p:nvPr/>
+        </p:nvSpPr>
+        <p:spPr>
+          <a:xfrm>
+            <a:off x="7434072" y="6400800"/>
+            <a:ext cx="4114800" cy="237744"/>
+          </a:xfrm>
+          <a:prstGeom prst="rect">
+            <a:avLst/>
+          </a:prstGeom>
+          <a:noFill/>
+          <a:ln/>
+        </p:spPr>
+        <p:txBody>
+          <a:bodyPr wrap="square" lIns="0" tIns="0" rIns="0" bIns="0" rtlCol="0" anchor="ctr"/>
+          <a:lstStyle/>
+          <a:p>
+            <a:pPr algn="r" indent="0" marL="0">
+              <a:buNone/>
+            </a:pPr>
+            <a:r>
+              <a:rPr lang="en-US" sz="800" b="1" spc="4000" kern="0" dirty="0">
+                <a:solidFill>
+                  <a:srgbClr val="9FB8B2"/>
+                </a:solidFill>
+                <a:latin typeface="Calibri" pitchFamily="34" charset="0"/>
+                <a:ea typeface="Calibri" pitchFamily="34" charset="-122"/>
+                <a:cs typeface="Calibri" pitchFamily="34" charset="-120"/>
+              </a:rPr>
+              <a:t>PROJECTIONS ILLUSTRATIVE · 12 / 12</a:t>
+            </a:r>
+            <a:endParaRPr lang="en-US" sz="800" dirty="0"/>
+          </a:p>
+        </p:txBody>
       </p:sp>
       <p:sp>
         <p:nvSpPr>
@@ -4772,8 +4921,67 @@
         </p:nvSpPr>
         <p:spPr>
           <a:xfrm>
+            <a:off x="640080" y="2176272"/>
+            <a:ext cx="4572000" cy="256032"/>
+          </a:xfrm>
+          <a:prstGeom prst="rect">
+            <a:avLst/>
+          </a:prstGeom>
+          <a:noFill/>
+          <a:ln/>
+        </p:spPr>
+        <p:txBody>
+          <a:bodyPr wrap="square" lIns="0" tIns="0" rIns="0" bIns="0" rtlCol="0" anchor="ctr"/>
+          <a:lstStyle/>
+          <a:p>
+            <a:pPr algn="l" indent="0" marL="0">
+              <a:buNone/>
+            </a:pPr>
+            <a:r>
+              <a:rPr lang="en-US" sz="1000" b="1" spc="6000" kern="0" dirty="0">
+                <a:solidFill>
+                  <a:srgbClr val="9FB8B2"/>
+                </a:solidFill>
+                <a:latin typeface="Calibri" pitchFamily="34" charset="0"/>
+                <a:ea typeface="Calibri" pitchFamily="34" charset="-122"/>
+                <a:cs typeface="Calibri" pitchFamily="34" charset="-120"/>
+              </a:rPr>
+              <a:t>USE OF FUNDS</a:t>
+            </a:r>
+            <a:endParaRPr lang="en-US" sz="1000" dirty="0"/>
+          </a:p>
+        </p:txBody>
+      </p:sp>
+      <p:sp>
+        <p:nvSpPr>
+          <p:cNvPr id="9" name="Shape 7"/>
+          <p:cNvSpPr/>
+          <p:nvPr/>
+        </p:nvSpPr>
+        <p:spPr>
+          <a:xfrm>
+            <a:off x="640080" y="2834640"/>
+            <a:ext cx="4809744" cy="548640"/>
+          </a:xfrm>
+          <a:prstGeom prst="rect">
+            <a:avLst/>
+          </a:prstGeom>
+          <a:solidFill>
+            <a:srgbClr val="3ECFA0"/>
+          </a:solidFill>
+          <a:ln/>
+        </p:spPr>
+      </p:sp>
+      <p:sp>
+        <p:nvSpPr>
+          <p:cNvPr id="10" name="Text 8"/>
+          <p:cNvSpPr txBox="1"/>
+          <p:nvPr/>
+        </p:nvSpPr>
+        <p:spPr>
+          <a:xfrm>
             <a:off x="640080" y="2523744"/>
-            <a:ext cx="4837176" cy="274320"/>
+            <a:ext cx="4809744" cy="274320"/>
           </a:xfrm>
           <a:prstGeom prst="rect">
             <a:avLst/>
@@ -4805,14 +5013,14 @@
       </p:sp>
       <p:sp>
         <p:nvSpPr>
-          <p:cNvPr id="9" name="Text 7"/>
+          <p:cNvPr id="11" name="Text 9"/>
           <p:cNvSpPr txBox="1"/>
           <p:nvPr/>
         </p:nvSpPr>
         <p:spPr>
           <a:xfrm>
             <a:off x="768096" y="2907792"/>
-            <a:ext cx="4581144" cy="402336"/>
+            <a:ext cx="4553712" cy="402336"/>
           </a:xfrm>
           <a:prstGeom prst="rect">
             <a:avLst/>
@@ -4844,14 +5052,14 @@
       </p:sp>
       <p:sp>
         <p:nvSpPr>
-          <p:cNvPr id="10" name="Shape 8"/>
+          <p:cNvPr id="12" name="Shape 10"/>
           <p:cNvSpPr/>
           <p:nvPr/>
         </p:nvSpPr>
         <p:spPr>
           <a:xfrm>
-            <a:off x="5532120" y="2834640"/>
-            <a:ext cx="3227832" cy="548640"/>
+            <a:off x="5559552" y="2834640"/>
+            <a:ext cx="3209544" cy="548640"/>
           </a:xfrm>
           <a:prstGeom prst="rect">
             <a:avLst/>
@@ -4864,14 +5072,14 @@
       </p:sp>
       <p:sp>
         <p:nvSpPr>
-          <p:cNvPr id="11" name="Text 9"/>
-          <p:cNvSpPr txBox="1"/>
-          <p:nvPr/>
-        </p:nvSpPr>
-        <p:spPr>
-          <a:xfrm>
-            <a:off x="5532120" y="2523744"/>
-            <a:ext cx="3227832" cy="274320"/>
+          <p:cNvPr id="13" name="Text 11"/>
+          <p:cNvSpPr txBox="1"/>
+          <p:nvPr/>
+        </p:nvSpPr>
+        <p:spPr>
+          <a:xfrm>
+            <a:off x="5559552" y="2523744"/>
+            <a:ext cx="3209544" cy="274320"/>
           </a:xfrm>
           <a:prstGeom prst="rect">
             <a:avLst/>
@@ -4903,14 +5111,14 @@
       </p:sp>
       <p:sp>
         <p:nvSpPr>
-          <p:cNvPr id="12" name="Text 10"/>
-          <p:cNvSpPr txBox="1"/>
-          <p:nvPr/>
-        </p:nvSpPr>
-        <p:spPr>
-          <a:xfrm>
-            <a:off x="5660136" y="2907792"/>
-            <a:ext cx="2971800" cy="402336"/>
+          <p:cNvPr id="14" name="Text 12"/>
+          <p:cNvSpPr txBox="1"/>
+          <p:nvPr/>
+        </p:nvSpPr>
+        <p:spPr>
+          <a:xfrm>
+            <a:off x="5687568" y="2907792"/>
+            <a:ext cx="2953512" cy="402336"/>
           </a:xfrm>
           <a:prstGeom prst="rect">
             <a:avLst/>
@@ -4942,14 +5150,14 @@
       </p:sp>
       <p:sp>
         <p:nvSpPr>
-          <p:cNvPr id="13" name="Shape 11"/>
+          <p:cNvPr id="15" name="Shape 13"/>
           <p:cNvSpPr/>
           <p:nvPr/>
         </p:nvSpPr>
         <p:spPr>
           <a:xfrm>
-            <a:off x="8805672" y="2834640"/>
-            <a:ext cx="2688336" cy="548640"/>
+            <a:off x="8878824" y="2834640"/>
+            <a:ext cx="2670048" cy="548640"/>
           </a:xfrm>
           <a:prstGeom prst="rect">
             <a:avLst/>
@@ -4962,14 +5170,14 @@
       </p:sp>
       <p:sp>
         <p:nvSpPr>
-          <p:cNvPr id="14" name="Text 12"/>
-          <p:cNvSpPr txBox="1"/>
-          <p:nvPr/>
-        </p:nvSpPr>
-        <p:spPr>
-          <a:xfrm>
-            <a:off x="8805672" y="2523744"/>
-            <a:ext cx="2688336" cy="274320"/>
+          <p:cNvPr id="16" name="Text 14"/>
+          <p:cNvSpPr txBox="1"/>
+          <p:nvPr/>
+        </p:nvSpPr>
+        <p:spPr>
+          <a:xfrm>
+            <a:off x="8878824" y="2523744"/>
+            <a:ext cx="2670048" cy="274320"/>
           </a:xfrm>
           <a:prstGeom prst="rect">
             <a:avLst/>
@@ -5001,14 +5209,14 @@
       </p:sp>
       <p:sp>
         <p:nvSpPr>
-          <p:cNvPr id="15" name="Text 13"/>
-          <p:cNvSpPr txBox="1"/>
-          <p:nvPr/>
-        </p:nvSpPr>
-        <p:spPr>
-          <a:xfrm>
-            <a:off x="8933688" y="2907792"/>
-            <a:ext cx="2432304" cy="402336"/>
+          <p:cNvPr id="17" name="Text 15"/>
+          <p:cNvSpPr txBox="1"/>
+          <p:nvPr/>
+        </p:nvSpPr>
+        <p:spPr>
+          <a:xfrm>
+            <a:off x="9006840" y="2907792"/>
+            <a:ext cx="2414016" cy="402336"/>
           </a:xfrm>
           <a:prstGeom prst="rect">
             <a:avLst/>
@@ -5040,7 +5248,7 @@
       </p:sp>
       <p:sp>
         <p:nvSpPr>
-          <p:cNvPr id="16" name="Text 14"/>
+          <p:cNvPr id="18" name="Text 16"/>
           <p:cNvSpPr txBox="1"/>
           <p:nvPr/>
         </p:nvSpPr>
@@ -5079,7 +5287,7 @@
       </p:sp>
       <p:sp>
         <p:nvSpPr>
-          <p:cNvPr id="17" name="Shape 15"/>
+          <p:cNvPr id="19" name="Shape 17"/>
           <p:cNvSpPr/>
           <p:nvPr/>
         </p:nvSpPr>
@@ -5106,7 +5314,7 @@
       </p:sp>
       <p:pic>
         <p:nvPicPr>
-          <p:cNvPr id="18" name="Image 0" descr="preencoded.png">    </p:cNvPr>
+          <p:cNvPr id="20" name="Image 0" descr="preencoded.png">    </p:cNvPr>
           <p:cNvPicPr>
             <a:picLocks noChangeAspect="1"/>
           </p:cNvPicPr>
@@ -5130,14 +5338,14 @@
       </p:pic>
       <p:sp>
         <p:nvSpPr>
-          <p:cNvPr id="19" name="Text 16"/>
+          <p:cNvPr id="21" name="Text 18"/>
           <p:cNvSpPr txBox="1"/>
           <p:nvPr/>
         </p:nvSpPr>
         <p:spPr>
           <a:xfrm>
             <a:off x="1444752" y="4389120"/>
-            <a:ext cx="2496312" cy="786384"/>
+            <a:ext cx="2395728" cy="786384"/>
           </a:xfrm>
           <a:prstGeom prst="rect">
             <a:avLst/>
@@ -5169,7 +5377,7 @@
       </p:sp>
       <p:sp>
         <p:nvSpPr>
-          <p:cNvPr id="20" name="Shape 17"/>
+          <p:cNvPr id="22" name="Shape 19"/>
           <p:cNvSpPr/>
           <p:nvPr/>
         </p:nvSpPr>
@@ -5196,7 +5404,7 @@
       </p:sp>
       <p:pic>
         <p:nvPicPr>
-          <p:cNvPr id="21" name="Image 1" descr="preencoded.png">    </p:cNvPr>
+          <p:cNvPr id="23" name="Image 1" descr="preencoded.png">    </p:cNvPr>
           <p:cNvPicPr>
             <a:picLocks noChangeAspect="1"/>
           </p:cNvPicPr>
@@ -5220,14 +5428,14 @@
       </p:pic>
       <p:sp>
         <p:nvSpPr>
-          <p:cNvPr id="22" name="Text 18"/>
+          <p:cNvPr id="24" name="Text 20"/>
           <p:cNvSpPr txBox="1"/>
           <p:nvPr/>
         </p:nvSpPr>
         <p:spPr>
           <a:xfrm>
             <a:off x="5166360" y="4389120"/>
-            <a:ext cx="2496312" cy="786384"/>
+            <a:ext cx="2395728" cy="786384"/>
           </a:xfrm>
           <a:prstGeom prst="rect">
             <a:avLst/>
@@ -5259,7 +5467,7 @@
       </p:sp>
       <p:sp>
         <p:nvSpPr>
-          <p:cNvPr id="23" name="Shape 19"/>
+          <p:cNvPr id="25" name="Shape 21"/>
           <p:cNvSpPr/>
           <p:nvPr/>
         </p:nvSpPr>
@@ -5286,7 +5494,7 @@
       </p:sp>
       <p:pic>
         <p:nvPicPr>
-          <p:cNvPr id="24" name="Image 2" descr="preencoded.png">    </p:cNvPr>
+          <p:cNvPr id="26" name="Image 2" descr="preencoded.png">    </p:cNvPr>
           <p:cNvPicPr>
             <a:picLocks noChangeAspect="1"/>
           </p:cNvPicPr>
@@ -5310,14 +5518,14 @@
       </p:pic>
       <p:sp>
         <p:nvSpPr>
-          <p:cNvPr id="25" name="Text 20"/>
+          <p:cNvPr id="27" name="Text 22"/>
           <p:cNvSpPr txBox="1"/>
           <p:nvPr/>
         </p:nvSpPr>
         <p:spPr>
           <a:xfrm>
             <a:off x="8887968" y="4389120"/>
-            <a:ext cx="2496312" cy="786384"/>
+            <a:ext cx="2395728" cy="786384"/>
           </a:xfrm>
           <a:prstGeom prst="rect">
             <a:avLst/>
@@ -5349,7 +5557,7 @@
       </p:sp>
       <p:sp>
         <p:nvSpPr>
-          <p:cNvPr id="26" name="Text 21"/>
+          <p:cNvPr id="28" name="Text 23"/>
           <p:cNvSpPr txBox="1"/>
           <p:nvPr/>
         </p:nvSpPr>
@@ -5388,7 +5596,7 @@
       </p:sp>
       <p:sp>
         <p:nvSpPr>
-          <p:cNvPr id="27" name="Text 22"/>
+          <p:cNvPr id="29" name="Text 24"/>
           <p:cNvSpPr txBox="1"/>
           <p:nvPr/>
         </p:nvSpPr>
@@ -5554,14 +5762,66 @@
       </p:sp>
       <p:sp>
         <p:nvSpPr>
-          <p:cNvPr id="4" name="Text 2"/>
-          <p:cNvSpPr txBox="1"/>
-          <p:nvPr/>
-        </p:nvSpPr>
-        <p:spPr>
-          <a:xfrm>
-            <a:off x="640080" y="6510528"/>
-            <a:ext cx="3657600" cy="237744"/>
+          <p:cNvPr id="4" name="Shape 2"/>
+          <p:cNvSpPr/>
+          <p:nvPr/>
+        </p:nvSpPr>
+        <p:spPr>
+          <a:xfrm>
+            <a:off x="640080" y="6382512"/>
+            <a:ext cx="274320" cy="274320"/>
+          </a:xfrm>
+          <a:prstGeom prst="roundRect">
+            <a:avLst>
+              <a:gd name="adj" fmla="val 21800"/>
+            </a:avLst>
+          </a:prstGeom>
+          <a:solidFill>
+            <a:srgbClr val="3ECFA0"/>
+          </a:solidFill>
+          <a:ln w="12700">
+            <a:solidFill>
+              <a:srgbClr val="3ECFA0"/>
+            </a:solidFill>
+            <a:prstDash val="solid"/>
+          </a:ln>
+        </p:spPr>
+      </p:sp>
+      <p:sp>
+        <p:nvSpPr>
+          <p:cNvPr id="5" name="Shape 3"/>
+          <p:cNvSpPr/>
+          <p:nvPr/>
+        </p:nvSpPr>
+        <p:spPr>
+          <a:xfrm>
+            <a:off x="717438" y="6459870"/>
+            <a:ext cx="119604" cy="119604"/>
+          </a:xfrm>
+          <a:prstGeom prst="ellipse">
+            <a:avLst/>
+          </a:prstGeom>
+          <a:solidFill>
+            <a:srgbClr val="3ECFA0"/>
+          </a:solidFill>
+          <a:ln w="13868">
+            <a:solidFill>
+              <a:srgbClr val="0B1A19"/>
+            </a:solidFill>
+            <a:prstDash val="solid"/>
+          </a:ln>
+        </p:spPr>
+      </p:sp>
+      <p:sp>
+        <p:nvSpPr>
+          <p:cNvPr id="6" name="Text 4"/>
+          <p:cNvSpPr txBox="1"/>
+          <p:nvPr/>
+        </p:nvSpPr>
+        <p:spPr>
+          <a:xfrm>
+            <a:off x="1005840" y="6400800"/>
+            <a:ext cx="3291840" cy="237744"/>
           </a:xfrm>
           <a:prstGeom prst="rect">
             <a:avLst/>
@@ -5593,13 +5853,13 @@
       </p:sp>
       <p:sp>
         <p:nvSpPr>
-          <p:cNvPr id="5" name="Text 3"/>
-          <p:cNvSpPr txBox="1"/>
-          <p:nvPr/>
-        </p:nvSpPr>
-        <p:spPr>
-          <a:xfrm>
-            <a:off x="7434072" y="6510528"/>
+          <p:cNvPr id="7" name="Text 5"/>
+          <p:cNvSpPr txBox="1"/>
+          <p:nvPr/>
+        </p:nvSpPr>
+        <p:spPr>
+          <a:xfrm>
+            <a:off x="7434072" y="6400800"/>
             <a:ext cx="4114800" cy="237744"/>
           </a:xfrm>
           <a:prstGeom prst="rect">
@@ -5632,7 +5892,7 @@
       </p:sp>
       <p:sp>
         <p:nvSpPr>
-          <p:cNvPr id="6" name="Shape 4"/>
+          <p:cNvPr id="8" name="Shape 6"/>
           <p:cNvSpPr/>
           <p:nvPr/>
         </p:nvSpPr>
@@ -5657,7 +5917,7 @@
       </p:sp>
       <p:pic>
         <p:nvPicPr>
-          <p:cNvPr id="7" name="Image 0" descr="preencoded.png">    </p:cNvPr>
+          <p:cNvPr id="9" name="Image 0" descr="preencoded.png">    </p:cNvPr>
           <p:cNvPicPr>
             <a:picLocks noChangeAspect="1"/>
           </p:cNvPicPr>
@@ -5681,7 +5941,7 @@
       </p:pic>
       <p:sp>
         <p:nvSpPr>
-          <p:cNvPr id="8" name="Text 5"/>
+          <p:cNvPr id="10" name="Text 7"/>
           <p:cNvSpPr txBox="1"/>
           <p:nvPr/>
         </p:nvSpPr>
@@ -5720,7 +5980,7 @@
       </p:sp>
       <p:sp>
         <p:nvSpPr>
-          <p:cNvPr id="9" name="Text 6"/>
+          <p:cNvPr id="11" name="Text 8"/>
           <p:cNvSpPr txBox="1"/>
           <p:nvPr/>
         </p:nvSpPr>
@@ -5759,7 +6019,7 @@
       </p:sp>
       <p:sp>
         <p:nvSpPr>
-          <p:cNvPr id="10" name="Shape 7"/>
+          <p:cNvPr id="12" name="Shape 9"/>
           <p:cNvSpPr/>
           <p:nvPr/>
         </p:nvSpPr>
@@ -5784,7 +6044,7 @@
       </p:sp>
       <p:pic>
         <p:nvPicPr>
-          <p:cNvPr id="11" name="Image 1" descr="preencoded.png">    </p:cNvPr>
+          <p:cNvPr id="13" name="Image 1" descr="preencoded.png">    </p:cNvPr>
           <p:cNvPicPr>
             <a:picLocks noChangeAspect="1"/>
           </p:cNvPicPr>
@@ -5808,7 +6068,7 @@
       </p:pic>
       <p:sp>
         <p:nvSpPr>
-          <p:cNvPr id="12" name="Text 8"/>
+          <p:cNvPr id="14" name="Text 10"/>
           <p:cNvSpPr txBox="1"/>
           <p:nvPr/>
         </p:nvSpPr>
@@ -5847,7 +6107,7 @@
       </p:sp>
       <p:sp>
         <p:nvSpPr>
-          <p:cNvPr id="13" name="Text 9"/>
+          <p:cNvPr id="15" name="Text 11"/>
           <p:cNvSpPr txBox="1"/>
           <p:nvPr/>
         </p:nvSpPr>
@@ -5886,7 +6146,7 @@
       </p:sp>
       <p:sp>
         <p:nvSpPr>
-          <p:cNvPr id="14" name="Shape 10"/>
+          <p:cNvPr id="16" name="Shape 12"/>
           <p:cNvSpPr/>
           <p:nvPr/>
         </p:nvSpPr>
@@ -5911,7 +6171,7 @@
       </p:sp>
       <p:pic>
         <p:nvPicPr>
-          <p:cNvPr id="15" name="Image 2" descr="preencoded.png">    </p:cNvPr>
+          <p:cNvPr id="17" name="Image 2" descr="preencoded.png">    </p:cNvPr>
           <p:cNvPicPr>
             <a:picLocks noChangeAspect="1"/>
           </p:cNvPicPr>
@@ -5935,7 +6195,7 @@
       </p:pic>
       <p:sp>
         <p:nvSpPr>
-          <p:cNvPr id="16" name="Text 11"/>
+          <p:cNvPr id="18" name="Text 13"/>
           <p:cNvSpPr txBox="1"/>
           <p:nvPr/>
         </p:nvSpPr>
@@ -5974,7 +6234,7 @@
       </p:sp>
       <p:sp>
         <p:nvSpPr>
-          <p:cNvPr id="17" name="Text 12"/>
+          <p:cNvPr id="19" name="Text 14"/>
           <p:cNvSpPr txBox="1"/>
           <p:nvPr/>
         </p:nvSpPr>
@@ -6013,7 +6273,7 @@
       </p:sp>
       <p:sp>
         <p:nvSpPr>
-          <p:cNvPr id="18" name="Shape 13"/>
+          <p:cNvPr id="20" name="Shape 15"/>
           <p:cNvSpPr/>
           <p:nvPr/>
         </p:nvSpPr>
@@ -6040,7 +6300,7 @@
       </p:sp>
       <p:sp>
         <p:nvSpPr>
-          <p:cNvPr id="19" name="Text 14"/>
+          <p:cNvPr id="21" name="Text 16"/>
           <p:cNvSpPr txBox="1"/>
           <p:nvPr/>
         </p:nvSpPr>
@@ -6079,7 +6339,7 @@
       </p:sp>
       <p:sp>
         <p:nvSpPr>
-          <p:cNvPr id="20" name="Text 15"/>
+          <p:cNvPr id="22" name="Text 17"/>
           <p:cNvSpPr txBox="1"/>
           <p:nvPr/>
         </p:nvSpPr>
@@ -6118,7 +6378,7 @@
       </p:sp>
       <p:sp>
         <p:nvSpPr>
-          <p:cNvPr id="21" name="Shape 16"/>
+          <p:cNvPr id="23" name="Shape 18"/>
           <p:cNvSpPr/>
           <p:nvPr/>
         </p:nvSpPr>
@@ -6138,7 +6398,7 @@
       </p:sp>
       <p:sp>
         <p:nvSpPr>
-          <p:cNvPr id="22" name="Text 17"/>
+          <p:cNvPr id="24" name="Text 19"/>
           <p:cNvSpPr txBox="1"/>
           <p:nvPr/>
         </p:nvSpPr>
@@ -6177,7 +6437,7 @@
       </p:sp>
       <p:sp>
         <p:nvSpPr>
-          <p:cNvPr id="23" name="Text 18"/>
+          <p:cNvPr id="25" name="Text 20"/>
           <p:cNvSpPr txBox="1"/>
           <p:nvPr/>
         </p:nvSpPr>
@@ -6216,7 +6476,7 @@
       </p:sp>
       <p:sp>
         <p:nvSpPr>
-          <p:cNvPr id="24" name="Shape 19"/>
+          <p:cNvPr id="26" name="Shape 21"/>
           <p:cNvSpPr/>
           <p:nvPr/>
         </p:nvSpPr>
@@ -6236,7 +6496,7 @@
       </p:sp>
       <p:sp>
         <p:nvSpPr>
-          <p:cNvPr id="25" name="Text 20"/>
+          <p:cNvPr id="27" name="Text 22"/>
           <p:cNvSpPr txBox="1"/>
           <p:nvPr/>
         </p:nvSpPr>
@@ -6275,7 +6535,7 @@
       </p:sp>
       <p:sp>
         <p:nvSpPr>
-          <p:cNvPr id="26" name="Text 21"/>
+          <p:cNvPr id="28" name="Text 23"/>
           <p:cNvSpPr txBox="1"/>
           <p:nvPr/>
         </p:nvSpPr>
@@ -6314,18 +6574,18 @@
       </p:sp>
       <p:sp>
         <p:nvSpPr>
-          <p:cNvPr id="27" name="Shape 22"/>
+          <p:cNvPr id="29" name="Shape 24"/>
           <p:cNvSpPr/>
           <p:nvPr/>
         </p:nvSpPr>
         <p:spPr>
           <a:xfrm>
             <a:off x="7178040" y="2240280"/>
-            <a:ext cx="4370832" cy="3611880"/>
+            <a:ext cx="4370832" cy="3977640"/>
           </a:xfrm>
           <a:prstGeom prst="roundRect">
             <a:avLst>
-              <a:gd name="adj" fmla="val 3544"/>
+              <a:gd name="adj" fmla="val 3218"/>
             </a:avLst>
           </a:prstGeom>
           <a:solidFill>
@@ -6336,7 +6596,7 @@
       </p:sp>
       <p:sp>
         <p:nvSpPr>
-          <p:cNvPr id="28" name="Text 23"/>
+          <p:cNvPr id="30" name="Text 25"/>
           <p:cNvSpPr txBox="1"/>
           <p:nvPr/>
         </p:nvSpPr>
@@ -6375,14 +6635,14 @@
       </p:sp>
       <p:sp>
         <p:nvSpPr>
-          <p:cNvPr id="29" name="Text 24"/>
-          <p:cNvSpPr txBox="1"/>
-          <p:nvPr/>
-        </p:nvSpPr>
-        <p:spPr>
-          <a:xfrm>
-            <a:off x="7498080" y="2880360"/>
-            <a:ext cx="3749040" cy="1463040"/>
+          <p:cNvPr id="31" name="Text 26"/>
+          <p:cNvSpPr txBox="1"/>
+          <p:nvPr/>
+        </p:nvSpPr>
+        <p:spPr>
+          <a:xfrm>
+            <a:off x="7543800" y="2880360"/>
+            <a:ext cx="3657600" cy="1463040"/>
           </a:xfrm>
           <a:prstGeom prst="rect">
             <a:avLst/>
@@ -6414,13 +6674,13 @@
       </p:sp>
       <p:sp>
         <p:nvSpPr>
-          <p:cNvPr id="30" name="Text 25"/>
-          <p:cNvSpPr txBox="1"/>
-          <p:nvPr/>
-        </p:nvSpPr>
-        <p:spPr>
-          <a:xfrm>
-            <a:off x="7543800" y="4526280"/>
+          <p:cNvPr id="32" name="Text 27"/>
+          <p:cNvSpPr txBox="1"/>
+          <p:nvPr/>
+        </p:nvSpPr>
+        <p:spPr>
+          <a:xfrm>
+            <a:off x="7543800" y="4709160"/>
             <a:ext cx="3657600" cy="320040"/>
           </a:xfrm>
           <a:prstGeom prst="rect">
@@ -6453,13 +6713,13 @@
       </p:sp>
       <p:sp>
         <p:nvSpPr>
-          <p:cNvPr id="31" name="Text 26"/>
-          <p:cNvSpPr txBox="1"/>
-          <p:nvPr/>
-        </p:nvSpPr>
-        <p:spPr>
-          <a:xfrm>
-            <a:off x="7543800" y="5212080"/>
+          <p:cNvPr id="33" name="Text 28"/>
+          <p:cNvSpPr txBox="1"/>
+          <p:nvPr/>
+        </p:nvSpPr>
+        <p:spPr>
+          <a:xfrm>
+            <a:off x="7543800" y="5440680"/>
             <a:ext cx="3657600" cy="411480"/>
           </a:xfrm>
           <a:prstGeom prst="rect">
@@ -6608,96 +6868,148 @@
       </p:sp>
       <p:sp>
         <p:nvSpPr>
-          <p:cNvPr id="4" name="Text 2"/>
-          <p:cNvSpPr txBox="1"/>
-          <p:nvPr/>
-        </p:nvSpPr>
-        <p:spPr>
-          <a:xfrm>
-            <a:off x="640080" y="6510528"/>
-            <a:ext cx="3657600" cy="237744"/>
-          </a:xfrm>
-          <a:prstGeom prst="rect">
-            <a:avLst/>
-          </a:prstGeom>
-          <a:noFill/>
-          <a:ln/>
-        </p:spPr>
-        <p:txBody>
-          <a:bodyPr wrap="square" lIns="0" tIns="0" rIns="0" bIns="0" rtlCol="0" anchor="ctr"/>
-          <a:lstStyle/>
-          <a:p>
-            <a:pPr algn="l" indent="0" marL="0">
-              <a:buNone/>
-            </a:pPr>
-            <a:r>
-              <a:rPr lang="en-US" sz="800" b="1" spc="4000" kern="0" dirty="0">
-                <a:solidFill>
-                  <a:srgbClr val="4F6B66"/>
-                </a:solidFill>
-                <a:latin typeface="Calibri" pitchFamily="34" charset="0"/>
-                <a:ea typeface="Calibri" pitchFamily="34" charset="-122"/>
-                <a:cs typeface="Calibri" pitchFamily="34" charset="-120"/>
-              </a:rPr>
-              <a:t>MERIDIAN · APPIFY SOFTWARES</a:t>
-            </a:r>
-            <a:endParaRPr lang="en-US" sz="800" dirty="0"/>
-          </a:p>
-        </p:txBody>
-      </p:sp>
-      <p:sp>
-        <p:nvSpPr>
-          <p:cNvPr id="5" name="Text 3"/>
-          <p:cNvSpPr txBox="1"/>
-          <p:nvPr/>
-        </p:nvSpPr>
-        <p:spPr>
-          <a:xfrm>
-            <a:off x="7434072" y="6510528"/>
-            <a:ext cx="4114800" cy="237744"/>
-          </a:xfrm>
-          <a:prstGeom prst="rect">
-            <a:avLst/>
-          </a:prstGeom>
-          <a:noFill/>
-          <a:ln/>
-        </p:spPr>
-        <p:txBody>
-          <a:bodyPr wrap="square" lIns="0" tIns="0" rIns="0" bIns="0" rtlCol="0" anchor="ctr"/>
-          <a:lstStyle/>
-          <a:p>
-            <a:pPr algn="r" indent="0" marL="0">
-              <a:buNone/>
-            </a:pPr>
-            <a:r>
-              <a:rPr lang="en-US" sz="800" b="1" spc="4000" kern="0" dirty="0">
-                <a:solidFill>
-                  <a:srgbClr val="4F6B66"/>
-                </a:solidFill>
-                <a:latin typeface="Calibri" pitchFamily="34" charset="0"/>
-                <a:ea typeface="Calibri" pitchFamily="34" charset="-122"/>
-                <a:cs typeface="Calibri" pitchFamily="34" charset="-120"/>
-              </a:rPr>
-              <a:t>PROJECTIONS ILLUSTRATIVE · 03 / 12</a:t>
-            </a:r>
-            <a:endParaRPr lang="en-US" sz="800" dirty="0"/>
-          </a:p>
-        </p:txBody>
-      </p:sp>
-      <p:sp>
-        <p:nvSpPr>
-          <p:cNvPr id="6" name="Shape 4"/>
+          <p:cNvPr id="4" name="Shape 2"/>
           <p:cNvSpPr/>
           <p:nvPr/>
         </p:nvSpPr>
         <p:spPr>
           <a:xfrm>
-            <a:off x="640080" y="2286000"/>
-            <a:ext cx="3310128" cy="2423160"/>
+            <a:off x="640080" y="6382512"/>
+            <a:ext cx="274320" cy="274320"/>
           </a:xfrm>
           <a:prstGeom prst="roundRect">
             <a:avLst>
-              <a:gd name="adj" fmla="val 4528"/>
+              <a:gd name="adj" fmla="val 21800"/>
+            </a:avLst>
+          </a:prstGeom>
+          <a:solidFill>
+            <a:srgbClr val="3ECFA0"/>
+          </a:solidFill>
+          <a:ln w="12700">
+            <a:solidFill>
+              <a:srgbClr val="3ECFA0"/>
+            </a:solidFill>
+            <a:prstDash val="solid"/>
+          </a:ln>
+        </p:spPr>
+      </p:sp>
+      <p:sp>
+        <p:nvSpPr>
+          <p:cNvPr id="5" name="Shape 3"/>
+          <p:cNvSpPr/>
+          <p:nvPr/>
+        </p:nvSpPr>
+        <p:spPr>
+          <a:xfrm>
+            <a:off x="717438" y="6459870"/>
+            <a:ext cx="119604" cy="119604"/>
+          </a:xfrm>
+          <a:prstGeom prst="ellipse">
+            <a:avLst/>
+          </a:prstGeom>
+          <a:solidFill>
+            <a:srgbClr val="3ECFA0"/>
+          </a:solidFill>
+          <a:ln w="13868">
+            <a:solidFill>
+              <a:srgbClr val="0B1A19"/>
+            </a:solidFill>
+            <a:prstDash val="solid"/>
+          </a:ln>
+        </p:spPr>
+      </p:sp>
+      <p:sp>
+        <p:nvSpPr>
+          <p:cNvPr id="6" name="Text 4"/>
+          <p:cNvSpPr txBox="1"/>
+          <p:nvPr/>
+        </p:nvSpPr>
+        <p:spPr>
+          <a:xfrm>
+            <a:off x="1005840" y="6400800"/>
+            <a:ext cx="3291840" cy="237744"/>
+          </a:xfrm>
+          <a:prstGeom prst="rect">
+            <a:avLst/>
+          </a:prstGeom>
+          <a:noFill/>
+          <a:ln/>
+        </p:spPr>
+        <p:txBody>
+          <a:bodyPr wrap="square" lIns="0" tIns="0" rIns="0" bIns="0" rtlCol="0" anchor="ctr"/>
+          <a:lstStyle/>
+          <a:p>
+            <a:pPr algn="l" indent="0" marL="0">
+              <a:buNone/>
+            </a:pPr>
+            <a:r>
+              <a:rPr lang="en-US" sz="800" b="1" spc="4000" kern="0" dirty="0">
+                <a:solidFill>
+                  <a:srgbClr val="4F6B66"/>
+                </a:solidFill>
+                <a:latin typeface="Calibri" pitchFamily="34" charset="0"/>
+                <a:ea typeface="Calibri" pitchFamily="34" charset="-122"/>
+                <a:cs typeface="Calibri" pitchFamily="34" charset="-120"/>
+              </a:rPr>
+              <a:t>MERIDIAN · APPIFY SOFTWARES</a:t>
+            </a:r>
+            <a:endParaRPr lang="en-US" sz="800" dirty="0"/>
+          </a:p>
+        </p:txBody>
+      </p:sp>
+      <p:sp>
+        <p:nvSpPr>
+          <p:cNvPr id="7" name="Text 5"/>
+          <p:cNvSpPr txBox="1"/>
+          <p:nvPr/>
+        </p:nvSpPr>
+        <p:spPr>
+          <a:xfrm>
+            <a:off x="7434072" y="6400800"/>
+            <a:ext cx="4114800" cy="237744"/>
+          </a:xfrm>
+          <a:prstGeom prst="rect">
+            <a:avLst/>
+          </a:prstGeom>
+          <a:noFill/>
+          <a:ln/>
+        </p:spPr>
+        <p:txBody>
+          <a:bodyPr wrap="square" lIns="0" tIns="0" rIns="0" bIns="0" rtlCol="0" anchor="ctr"/>
+          <a:lstStyle/>
+          <a:p>
+            <a:pPr algn="r" indent="0" marL="0">
+              <a:buNone/>
+            </a:pPr>
+            <a:r>
+              <a:rPr lang="en-US" sz="800" b="1" spc="4000" kern="0" dirty="0">
+                <a:solidFill>
+                  <a:srgbClr val="4F6B66"/>
+                </a:solidFill>
+                <a:latin typeface="Calibri" pitchFamily="34" charset="0"/>
+                <a:ea typeface="Calibri" pitchFamily="34" charset="-122"/>
+                <a:cs typeface="Calibri" pitchFamily="34" charset="-120"/>
+              </a:rPr>
+              <a:t>PROJECTIONS ILLUSTRATIVE · 03 / 12</a:t>
+            </a:r>
+            <a:endParaRPr lang="en-US" sz="800" dirty="0"/>
+          </a:p>
+        </p:txBody>
+      </p:sp>
+      <p:sp>
+        <p:nvSpPr>
+          <p:cNvPr id="8" name="Shape 6"/>
+          <p:cNvSpPr/>
+          <p:nvPr/>
+        </p:nvSpPr>
+        <p:spPr>
+          <a:xfrm>
+            <a:off x="640080" y="2286000"/>
+            <a:ext cx="3310128" cy="2523744"/>
+          </a:xfrm>
+          <a:prstGeom prst="roundRect">
+            <a:avLst>
+              <a:gd name="adj" fmla="val 4348"/>
             </a:avLst>
           </a:prstGeom>
           <a:solidFill>
@@ -6713,7 +7025,7 @@
       </p:sp>
       <p:sp>
         <p:nvSpPr>
-          <p:cNvPr id="7" name="Shape 5"/>
+          <p:cNvPr id="9" name="Shape 7"/>
           <p:cNvSpPr/>
           <p:nvPr/>
         </p:nvSpPr>
@@ -6738,7 +7050,7 @@
       </p:sp>
       <p:pic>
         <p:nvPicPr>
-          <p:cNvPr id="8" name="Image 0" descr="preencoded.png">    </p:cNvPr>
+          <p:cNvPr id="10" name="Image 0" descr="preencoded.png">    </p:cNvPr>
           <p:cNvPicPr>
             <a:picLocks noChangeAspect="1"/>
           </p:cNvPicPr>
@@ -6762,14 +7074,14 @@
       </p:pic>
       <p:sp>
         <p:nvSpPr>
-          <p:cNvPr id="9" name="Text 6"/>
+          <p:cNvPr id="11" name="Text 8"/>
           <p:cNvSpPr txBox="1"/>
           <p:nvPr/>
         </p:nvSpPr>
         <p:spPr>
           <a:xfrm>
             <a:off x="932688" y="3419856"/>
-            <a:ext cx="2761488" cy="237744"/>
+            <a:ext cx="2724912" cy="237744"/>
           </a:xfrm>
           <a:prstGeom prst="rect">
             <a:avLst/>
@@ -6801,14 +7113,14 @@
       </p:sp>
       <p:sp>
         <p:nvSpPr>
-          <p:cNvPr id="10" name="Text 7"/>
+          <p:cNvPr id="12" name="Text 9"/>
           <p:cNvSpPr txBox="1"/>
           <p:nvPr/>
         </p:nvSpPr>
         <p:spPr>
           <a:xfrm>
             <a:off x="932688" y="3657600"/>
-            <a:ext cx="2761488" cy="329184"/>
+            <a:ext cx="2724912" cy="329184"/>
           </a:xfrm>
           <a:prstGeom prst="rect">
             <a:avLst/>
@@ -6840,14 +7152,14 @@
       </p:sp>
       <p:sp>
         <p:nvSpPr>
-          <p:cNvPr id="11" name="Text 8"/>
+          <p:cNvPr id="13" name="Text 10"/>
           <p:cNvSpPr txBox="1"/>
           <p:nvPr/>
         </p:nvSpPr>
         <p:spPr>
           <a:xfrm>
             <a:off x="932688" y="4023360"/>
-            <a:ext cx="2761488" cy="566928"/>
+            <a:ext cx="2724912" cy="566928"/>
           </a:xfrm>
           <a:prstGeom prst="rect">
             <a:avLst/>
@@ -6882,18 +7194,18 @@
       </p:sp>
       <p:sp>
         <p:nvSpPr>
-          <p:cNvPr id="12" name="Shape 9"/>
+          <p:cNvPr id="14" name="Shape 11"/>
           <p:cNvSpPr/>
           <p:nvPr/>
         </p:nvSpPr>
         <p:spPr>
           <a:xfrm>
             <a:off x="4434840" y="2286000"/>
-            <a:ext cx="3310128" cy="2423160"/>
+            <a:ext cx="3310128" cy="2523744"/>
           </a:xfrm>
           <a:prstGeom prst="roundRect">
             <a:avLst>
-              <a:gd name="adj" fmla="val 4528"/>
+              <a:gd name="adj" fmla="val 4348"/>
             </a:avLst>
           </a:prstGeom>
           <a:solidFill>
@@ -6909,7 +7221,7 @@
       </p:sp>
       <p:sp>
         <p:nvSpPr>
-          <p:cNvPr id="13" name="Shape 10"/>
+          <p:cNvPr id="15" name="Shape 12"/>
           <p:cNvSpPr/>
           <p:nvPr/>
         </p:nvSpPr>
@@ -6934,7 +7246,7 @@
       </p:sp>
       <p:pic>
         <p:nvPicPr>
-          <p:cNvPr id="14" name="Image 1" descr="preencoded.png">    </p:cNvPr>
+          <p:cNvPr id="16" name="Image 1" descr="preencoded.png">    </p:cNvPr>
           <p:cNvPicPr>
             <a:picLocks noChangeAspect="1"/>
           </p:cNvPicPr>
@@ -6958,14 +7270,14 @@
       </p:pic>
       <p:sp>
         <p:nvSpPr>
-          <p:cNvPr id="15" name="Text 11"/>
+          <p:cNvPr id="17" name="Text 13"/>
           <p:cNvSpPr txBox="1"/>
           <p:nvPr/>
         </p:nvSpPr>
         <p:spPr>
           <a:xfrm>
             <a:off x="4727448" y="3419856"/>
-            <a:ext cx="2761488" cy="237744"/>
+            <a:ext cx="2724912" cy="237744"/>
           </a:xfrm>
           <a:prstGeom prst="rect">
             <a:avLst/>
@@ -6997,14 +7309,14 @@
       </p:sp>
       <p:sp>
         <p:nvSpPr>
-          <p:cNvPr id="16" name="Text 12"/>
+          <p:cNvPr id="18" name="Text 14"/>
           <p:cNvSpPr txBox="1"/>
           <p:nvPr/>
         </p:nvSpPr>
         <p:spPr>
           <a:xfrm>
             <a:off x="4727448" y="3657600"/>
-            <a:ext cx="2761488" cy="329184"/>
+            <a:ext cx="2724912" cy="329184"/>
           </a:xfrm>
           <a:prstGeom prst="rect">
             <a:avLst/>
@@ -7036,14 +7348,14 @@
       </p:sp>
       <p:sp>
         <p:nvSpPr>
-          <p:cNvPr id="17" name="Text 13"/>
+          <p:cNvPr id="19" name="Text 15"/>
           <p:cNvSpPr txBox="1"/>
           <p:nvPr/>
         </p:nvSpPr>
         <p:spPr>
           <a:xfrm>
             <a:off x="4727448" y="4023360"/>
-            <a:ext cx="2761488" cy="566928"/>
+            <a:ext cx="2724912" cy="566928"/>
           </a:xfrm>
           <a:prstGeom prst="rect">
             <a:avLst/>
@@ -7078,18 +7390,18 @@
       </p:sp>
       <p:sp>
         <p:nvSpPr>
-          <p:cNvPr id="18" name="Shape 14"/>
+          <p:cNvPr id="20" name="Shape 16"/>
           <p:cNvSpPr/>
           <p:nvPr/>
         </p:nvSpPr>
         <p:spPr>
           <a:xfrm>
             <a:off x="8229600" y="2286000"/>
-            <a:ext cx="3310128" cy="2423160"/>
+            <a:ext cx="3310128" cy="2523744"/>
           </a:xfrm>
           <a:prstGeom prst="roundRect">
             <a:avLst>
-              <a:gd name="adj" fmla="val 4528"/>
+              <a:gd name="adj" fmla="val 4348"/>
             </a:avLst>
           </a:prstGeom>
           <a:solidFill>
@@ -7105,7 +7417,7 @@
       </p:sp>
       <p:sp>
         <p:nvSpPr>
-          <p:cNvPr id="19" name="Shape 15"/>
+          <p:cNvPr id="21" name="Shape 17"/>
           <p:cNvSpPr/>
           <p:nvPr/>
         </p:nvSpPr>
@@ -7130,7 +7442,7 @@
       </p:sp>
       <p:pic>
         <p:nvPicPr>
-          <p:cNvPr id="20" name="Image 2" descr="preencoded.png">    </p:cNvPr>
+          <p:cNvPr id="22" name="Image 2" descr="preencoded.png">    </p:cNvPr>
           <p:cNvPicPr>
             <a:picLocks noChangeAspect="1"/>
           </p:cNvPicPr>
@@ -7154,14 +7466,14 @@
       </p:pic>
       <p:sp>
         <p:nvSpPr>
-          <p:cNvPr id="21" name="Text 16"/>
+          <p:cNvPr id="23" name="Text 18"/>
           <p:cNvSpPr txBox="1"/>
           <p:nvPr/>
         </p:nvSpPr>
         <p:spPr>
           <a:xfrm>
             <a:off x="8522208" y="3419856"/>
-            <a:ext cx="2761488" cy="237744"/>
+            <a:ext cx="2724912" cy="237744"/>
           </a:xfrm>
           <a:prstGeom prst="rect">
             <a:avLst/>
@@ -7193,14 +7505,14 @@
       </p:sp>
       <p:sp>
         <p:nvSpPr>
-          <p:cNvPr id="22" name="Text 17"/>
+          <p:cNvPr id="24" name="Text 19"/>
           <p:cNvSpPr txBox="1"/>
           <p:nvPr/>
         </p:nvSpPr>
         <p:spPr>
           <a:xfrm>
             <a:off x="8522208" y="3657600"/>
-            <a:ext cx="2761488" cy="329184"/>
+            <a:ext cx="2724912" cy="329184"/>
           </a:xfrm>
           <a:prstGeom prst="rect">
             <a:avLst/>
@@ -7232,14 +7544,14 @@
       </p:sp>
       <p:sp>
         <p:nvSpPr>
-          <p:cNvPr id="23" name="Text 18"/>
+          <p:cNvPr id="25" name="Text 20"/>
           <p:cNvSpPr txBox="1"/>
           <p:nvPr/>
         </p:nvSpPr>
         <p:spPr>
           <a:xfrm>
             <a:off x="8522208" y="4023360"/>
-            <a:ext cx="2761488" cy="566928"/>
+            <a:ext cx="2724912" cy="566928"/>
           </a:xfrm>
           <a:prstGeom prst="rect">
             <a:avLst/>
@@ -7274,7 +7586,7 @@
       </p:sp>
       <p:sp>
         <p:nvSpPr>
-          <p:cNvPr id="24" name="Text 19"/>
+          <p:cNvPr id="26" name="Text 21"/>
           <p:cNvSpPr txBox="1"/>
           <p:nvPr/>
         </p:nvSpPr>
@@ -7313,7 +7625,7 @@
       </p:sp>
       <p:sp>
         <p:nvSpPr>
-          <p:cNvPr id="25" name="Text 20"/>
+          <p:cNvPr id="27" name="Text 22"/>
           <p:cNvSpPr txBox="1"/>
           <p:nvPr/>
         </p:nvSpPr>
@@ -7352,7 +7664,7 @@
       </p:sp>
       <p:sp>
         <p:nvSpPr>
-          <p:cNvPr id="26" name="Text 21"/>
+          <p:cNvPr id="28" name="Text 23"/>
           <p:cNvSpPr txBox="1"/>
           <p:nvPr/>
         </p:nvSpPr>
@@ -7405,7 +7717,7 @@
       </p:sp>
       <p:sp>
         <p:nvSpPr>
-          <p:cNvPr id="27" name="Text 22"/>
+          <p:cNvPr id="29" name="Text 24"/>
           <p:cNvSpPr txBox="1"/>
           <p:nvPr/>
         </p:nvSpPr>
@@ -7557,14 +7869,66 @@
       </p:sp>
       <p:sp>
         <p:nvSpPr>
-          <p:cNvPr id="4" name="Text 2"/>
-          <p:cNvSpPr txBox="1"/>
-          <p:nvPr/>
-        </p:nvSpPr>
-        <p:spPr>
-          <a:xfrm>
-            <a:off x="640080" y="6510528"/>
-            <a:ext cx="3657600" cy="237744"/>
+          <p:cNvPr id="4" name="Shape 2"/>
+          <p:cNvSpPr/>
+          <p:nvPr/>
+        </p:nvSpPr>
+        <p:spPr>
+          <a:xfrm>
+            <a:off x="640080" y="6382512"/>
+            <a:ext cx="274320" cy="274320"/>
+          </a:xfrm>
+          <a:prstGeom prst="roundRect">
+            <a:avLst>
+              <a:gd name="adj" fmla="val 21800"/>
+            </a:avLst>
+          </a:prstGeom>
+          <a:solidFill>
+            <a:srgbClr val="3ECFA0"/>
+          </a:solidFill>
+          <a:ln w="12700">
+            <a:solidFill>
+              <a:srgbClr val="3ECFA0"/>
+            </a:solidFill>
+            <a:prstDash val="solid"/>
+          </a:ln>
+        </p:spPr>
+      </p:sp>
+      <p:sp>
+        <p:nvSpPr>
+          <p:cNvPr id="5" name="Shape 3"/>
+          <p:cNvSpPr/>
+          <p:nvPr/>
+        </p:nvSpPr>
+        <p:spPr>
+          <a:xfrm>
+            <a:off x="717438" y="6459870"/>
+            <a:ext cx="119604" cy="119604"/>
+          </a:xfrm>
+          <a:prstGeom prst="ellipse">
+            <a:avLst/>
+          </a:prstGeom>
+          <a:solidFill>
+            <a:srgbClr val="3ECFA0"/>
+          </a:solidFill>
+          <a:ln w="13868">
+            <a:solidFill>
+              <a:srgbClr val="0B1A19"/>
+            </a:solidFill>
+            <a:prstDash val="solid"/>
+          </a:ln>
+        </p:spPr>
+      </p:sp>
+      <p:sp>
+        <p:nvSpPr>
+          <p:cNvPr id="6" name="Text 4"/>
+          <p:cNvSpPr txBox="1"/>
+          <p:nvPr/>
+        </p:nvSpPr>
+        <p:spPr>
+          <a:xfrm>
+            <a:off x="1005840" y="6400800"/>
+            <a:ext cx="3291840" cy="237744"/>
           </a:xfrm>
           <a:prstGeom prst="rect">
             <a:avLst/>
@@ -7596,13 +7960,13 @@
       </p:sp>
       <p:sp>
         <p:nvSpPr>
-          <p:cNvPr id="5" name="Text 3"/>
-          <p:cNvSpPr txBox="1"/>
-          <p:nvPr/>
-        </p:nvSpPr>
-        <p:spPr>
-          <a:xfrm>
-            <a:off x="7434072" y="6510528"/>
+          <p:cNvPr id="7" name="Text 5"/>
+          <p:cNvSpPr txBox="1"/>
+          <p:nvPr/>
+        </p:nvSpPr>
+        <p:spPr>
+          <a:xfrm>
+            <a:off x="7434072" y="6400800"/>
             <a:ext cx="4114800" cy="237744"/>
           </a:xfrm>
           <a:prstGeom prst="rect">
@@ -7635,7 +7999,7 @@
       </p:sp>
       <p:sp>
         <p:nvSpPr>
-          <p:cNvPr id="6" name="Shape 4"/>
+          <p:cNvPr id="8" name="Shape 6"/>
           <p:cNvSpPr/>
           <p:nvPr/>
         </p:nvSpPr>
@@ -7660,7 +8024,7 @@
       </p:sp>
       <p:pic>
         <p:nvPicPr>
-          <p:cNvPr id="7" name="Image 0" descr="preencoded.png">    </p:cNvPr>
+          <p:cNvPr id="9" name="Image 0" descr="preencoded.png">    </p:cNvPr>
           <p:cNvPicPr>
             <a:picLocks noChangeAspect="1"/>
           </p:cNvPicPr>
@@ -7684,7 +8048,7 @@
       </p:pic>
       <p:sp>
         <p:nvSpPr>
-          <p:cNvPr id="8" name="Text 5"/>
+          <p:cNvPr id="10" name="Text 7"/>
           <p:cNvSpPr txBox="1"/>
           <p:nvPr/>
         </p:nvSpPr>
@@ -7743,7 +8107,7 @@
       </p:sp>
       <p:sp>
         <p:nvSpPr>
-          <p:cNvPr id="9" name="Shape 6"/>
+          <p:cNvPr id="11" name="Shape 8"/>
           <p:cNvSpPr/>
           <p:nvPr/>
         </p:nvSpPr>
@@ -7768,7 +8132,7 @@
       </p:sp>
       <p:pic>
         <p:nvPicPr>
-          <p:cNvPr id="10" name="Image 1" descr="preencoded.png">    </p:cNvPr>
+          <p:cNvPr id="12" name="Image 1" descr="preencoded.png">    </p:cNvPr>
           <p:cNvPicPr>
             <a:picLocks noChangeAspect="1"/>
           </p:cNvPicPr>
@@ -7792,7 +8156,7 @@
       </p:pic>
       <p:sp>
         <p:nvSpPr>
-          <p:cNvPr id="11" name="Text 7"/>
+          <p:cNvPr id="13" name="Text 9"/>
           <p:cNvSpPr txBox="1"/>
           <p:nvPr/>
         </p:nvSpPr>
@@ -7851,7 +8215,7 @@
       </p:sp>
       <p:sp>
         <p:nvSpPr>
-          <p:cNvPr id="12" name="Shape 8"/>
+          <p:cNvPr id="14" name="Shape 10"/>
           <p:cNvSpPr/>
           <p:nvPr/>
         </p:nvSpPr>
@@ -7876,7 +8240,7 @@
       </p:sp>
       <p:pic>
         <p:nvPicPr>
-          <p:cNvPr id="13" name="Image 2" descr="preencoded.png">    </p:cNvPr>
+          <p:cNvPr id="15" name="Image 2" descr="preencoded.png">    </p:cNvPr>
           <p:cNvPicPr>
             <a:picLocks noChangeAspect="1"/>
           </p:cNvPicPr>
@@ -7900,7 +8264,7 @@
       </p:pic>
       <p:sp>
         <p:nvSpPr>
-          <p:cNvPr id="14" name="Text 9"/>
+          <p:cNvPr id="16" name="Text 11"/>
           <p:cNvSpPr txBox="1"/>
           <p:nvPr/>
         </p:nvSpPr>
@@ -7959,7 +8323,7 @@
       </p:sp>
       <p:sp>
         <p:nvSpPr>
-          <p:cNvPr id="15" name="Shape 10"/>
+          <p:cNvPr id="17" name="Shape 12"/>
           <p:cNvSpPr/>
           <p:nvPr/>
         </p:nvSpPr>
@@ -7986,7 +8350,7 @@
       </p:sp>
       <p:sp>
         <p:nvSpPr>
-          <p:cNvPr id="16" name="Text 11"/>
+          <p:cNvPr id="18" name="Text 13"/>
           <p:cNvSpPr txBox="1"/>
           <p:nvPr/>
         </p:nvSpPr>
@@ -8025,7 +8389,7 @@
       </p:sp>
       <p:sp>
         <p:nvSpPr>
-          <p:cNvPr id="17" name="Shape 12"/>
+          <p:cNvPr id="19" name="Shape 14"/>
           <p:cNvSpPr/>
           <p:nvPr/>
         </p:nvSpPr>
@@ -8052,7 +8416,7 @@
       </p:sp>
       <p:sp>
         <p:nvSpPr>
-          <p:cNvPr id="18" name="Text 13"/>
+          <p:cNvPr id="20" name="Text 15"/>
           <p:cNvSpPr txBox="1"/>
           <p:nvPr/>
         </p:nvSpPr>
@@ -8091,18 +8455,18 @@
       </p:sp>
       <p:sp>
         <p:nvSpPr>
-          <p:cNvPr id="19" name="Shape 14"/>
+          <p:cNvPr id="21" name="Shape 16"/>
           <p:cNvSpPr/>
           <p:nvPr/>
         </p:nvSpPr>
         <p:spPr>
           <a:xfrm>
             <a:off x="8732520" y="1463040"/>
-            <a:ext cx="2788920" cy="4754880"/>
+            <a:ext cx="2816352" cy="4754880"/>
           </a:xfrm>
           <a:prstGeom prst="roundRect">
             <a:avLst>
-              <a:gd name="adj" fmla="val 9836"/>
+              <a:gd name="adj" fmla="val 9740"/>
             </a:avLst>
           </a:prstGeom>
           <a:solidFill>
@@ -8113,18 +8477,18 @@
       </p:sp>
       <p:sp>
         <p:nvSpPr>
-          <p:cNvPr id="20" name="Shape 15"/>
+          <p:cNvPr id="22" name="Shape 17"/>
           <p:cNvSpPr/>
           <p:nvPr/>
         </p:nvSpPr>
         <p:spPr>
           <a:xfrm>
             <a:off x="8860536" y="1618488"/>
-            <a:ext cx="2532888" cy="4443984"/>
+            <a:ext cx="2560320" cy="4443984"/>
           </a:xfrm>
           <a:prstGeom prst="roundRect">
             <a:avLst>
-              <a:gd name="adj" fmla="val 7220"/>
+              <a:gd name="adj" fmla="val 7143"/>
             </a:avLst>
           </a:prstGeom>
           <a:solidFill>
@@ -8135,7 +8499,7 @@
       </p:sp>
       <p:sp>
         <p:nvSpPr>
-          <p:cNvPr id="21" name="Text 16"/>
+          <p:cNvPr id="23" name="Text 18"/>
           <p:cNvSpPr txBox="1"/>
           <p:nvPr/>
         </p:nvSpPr>
@@ -8188,7 +8552,7 @@
       </p:sp>
       <p:sp>
         <p:nvSpPr>
-          <p:cNvPr id="22" name="Shape 17"/>
+          <p:cNvPr id="24" name="Shape 19"/>
           <p:cNvSpPr/>
           <p:nvPr/>
         </p:nvSpPr>
@@ -8210,7 +8574,7 @@
       </p:sp>
       <p:sp>
         <p:nvSpPr>
-          <p:cNvPr id="23" name="Text 18"/>
+          <p:cNvPr id="25" name="Text 20"/>
           <p:cNvSpPr txBox="1"/>
           <p:nvPr/>
         </p:nvSpPr>
@@ -8272,7 +8636,7 @@
       </p:sp>
       <p:sp>
         <p:nvSpPr>
-          <p:cNvPr id="24" name="Shape 19"/>
+          <p:cNvPr id="26" name="Shape 21"/>
           <p:cNvSpPr/>
           <p:nvPr/>
         </p:nvSpPr>
@@ -8294,7 +8658,7 @@
       </p:sp>
       <p:sp>
         <p:nvSpPr>
-          <p:cNvPr id="25" name="Text 20"/>
+          <p:cNvPr id="27" name="Text 22"/>
           <p:cNvSpPr txBox="1"/>
           <p:nvPr/>
         </p:nvSpPr>
@@ -8356,7 +8720,7 @@
       </p:sp>
       <p:sp>
         <p:nvSpPr>
-          <p:cNvPr id="26" name="Shape 21"/>
+          <p:cNvPr id="28" name="Shape 23"/>
           <p:cNvSpPr/>
           <p:nvPr/>
         </p:nvSpPr>
@@ -8378,7 +8742,7 @@
       </p:sp>
       <p:sp>
         <p:nvSpPr>
-          <p:cNvPr id="27" name="Text 22"/>
+          <p:cNvPr id="29" name="Text 24"/>
           <p:cNvSpPr txBox="1"/>
           <p:nvPr/>
         </p:nvSpPr>
@@ -8440,7 +8804,7 @@
       </p:sp>
       <p:sp>
         <p:nvSpPr>
-          <p:cNvPr id="28" name="Text 23"/>
+          <p:cNvPr id="30" name="Text 25"/>
           <p:cNvSpPr txBox="1"/>
           <p:nvPr/>
         </p:nvSpPr>
@@ -8479,13 +8843,13 @@
       </p:sp>
       <p:sp>
         <p:nvSpPr>
-          <p:cNvPr id="29" name="Shape 24"/>
+          <p:cNvPr id="31" name="Shape 26"/>
           <p:cNvSpPr/>
           <p:nvPr/>
         </p:nvSpPr>
         <p:spPr>
           <a:xfrm>
-            <a:off x="9857232" y="5888736"/>
+            <a:off x="9866376" y="5888736"/>
             <a:ext cx="548640" cy="54864"/>
           </a:xfrm>
           <a:prstGeom prst="roundRect">
@@ -8614,14 +8978,66 @@
       </p:sp>
       <p:sp>
         <p:nvSpPr>
-          <p:cNvPr id="4" name="Text 2"/>
-          <p:cNvSpPr txBox="1"/>
-          <p:nvPr/>
-        </p:nvSpPr>
-        <p:spPr>
-          <a:xfrm>
-            <a:off x="640080" y="6510528"/>
-            <a:ext cx="3657600" cy="237744"/>
+          <p:cNvPr id="4" name="Shape 2"/>
+          <p:cNvSpPr/>
+          <p:nvPr/>
+        </p:nvSpPr>
+        <p:spPr>
+          <a:xfrm>
+            <a:off x="640080" y="6382512"/>
+            <a:ext cx="274320" cy="274320"/>
+          </a:xfrm>
+          <a:prstGeom prst="roundRect">
+            <a:avLst>
+              <a:gd name="adj" fmla="val 21800"/>
+            </a:avLst>
+          </a:prstGeom>
+          <a:solidFill>
+            <a:srgbClr val="3ECFA0"/>
+          </a:solidFill>
+          <a:ln w="12700">
+            <a:solidFill>
+              <a:srgbClr val="3ECFA0"/>
+            </a:solidFill>
+            <a:prstDash val="solid"/>
+          </a:ln>
+        </p:spPr>
+      </p:sp>
+      <p:sp>
+        <p:nvSpPr>
+          <p:cNvPr id="5" name="Shape 3"/>
+          <p:cNvSpPr/>
+          <p:nvPr/>
+        </p:nvSpPr>
+        <p:spPr>
+          <a:xfrm>
+            <a:off x="717438" y="6459870"/>
+            <a:ext cx="119604" cy="119604"/>
+          </a:xfrm>
+          <a:prstGeom prst="ellipse">
+            <a:avLst/>
+          </a:prstGeom>
+          <a:solidFill>
+            <a:srgbClr val="3ECFA0"/>
+          </a:solidFill>
+          <a:ln w="13868">
+            <a:solidFill>
+              <a:srgbClr val="0B1A19"/>
+            </a:solidFill>
+            <a:prstDash val="solid"/>
+          </a:ln>
+        </p:spPr>
+      </p:sp>
+      <p:sp>
+        <p:nvSpPr>
+          <p:cNvPr id="6" name="Text 4"/>
+          <p:cNvSpPr txBox="1"/>
+          <p:nvPr/>
+        </p:nvSpPr>
+        <p:spPr>
+          <a:xfrm>
+            <a:off x="1005840" y="6400800"/>
+            <a:ext cx="3291840" cy="237744"/>
           </a:xfrm>
           <a:prstGeom prst="rect">
             <a:avLst/>
@@ -8653,13 +9069,13 @@
       </p:sp>
       <p:sp>
         <p:nvSpPr>
-          <p:cNvPr id="5" name="Text 3"/>
-          <p:cNvSpPr txBox="1"/>
-          <p:nvPr/>
-        </p:nvSpPr>
-        <p:spPr>
-          <a:xfrm>
-            <a:off x="7434072" y="6510528"/>
+          <p:cNvPr id="7" name="Text 5"/>
+          <p:cNvSpPr txBox="1"/>
+          <p:nvPr/>
+        </p:nvSpPr>
+        <p:spPr>
+          <a:xfrm>
+            <a:off x="7434072" y="6400800"/>
             <a:ext cx="4114800" cy="237744"/>
           </a:xfrm>
           <a:prstGeom prst="rect">
@@ -8692,14 +9108,14 @@
       </p:sp>
       <p:sp>
         <p:nvSpPr>
-          <p:cNvPr id="6" name="Shape 4"/>
+          <p:cNvPr id="8" name="Shape 6"/>
           <p:cNvSpPr/>
           <p:nvPr/>
         </p:nvSpPr>
         <p:spPr>
           <a:xfrm>
             <a:off x="822960" y="2423160"/>
-            <a:ext cx="1554480" cy="3200400"/>
+            <a:ext cx="1554480" cy="3063240"/>
           </a:xfrm>
           <a:prstGeom prst="rect">
             <a:avLst/>
@@ -8712,7 +9128,7 @@
       </p:sp>
       <p:sp>
         <p:nvSpPr>
-          <p:cNvPr id="7" name="Text 5"/>
+          <p:cNvPr id="9" name="Text 7"/>
           <p:cNvSpPr txBox="1"/>
           <p:nvPr/>
         </p:nvSpPr>
@@ -8751,14 +9167,14 @@
       </p:sp>
       <p:sp>
         <p:nvSpPr>
-          <p:cNvPr id="8" name="Text 6"/>
-          <p:cNvSpPr txBox="1"/>
-          <p:nvPr/>
-        </p:nvSpPr>
-        <p:spPr>
-          <a:xfrm>
-            <a:off x="640080" y="5715000"/>
-            <a:ext cx="1920240" cy="685800"/>
+          <p:cNvPr id="10" name="Text 8"/>
+          <p:cNvSpPr txBox="1"/>
+          <p:nvPr/>
+        </p:nvSpPr>
+        <p:spPr>
+          <a:xfrm>
+            <a:off x="640080" y="5577840"/>
+            <a:ext cx="1920240" cy="640080"/>
           </a:xfrm>
           <a:prstGeom prst="rect">
             <a:avLst/>
@@ -8833,13 +9249,13 @@
       </p:sp>
       <p:sp>
         <p:nvSpPr>
-          <p:cNvPr id="9" name="Shape 7"/>
+          <p:cNvPr id="11" name="Shape 9"/>
           <p:cNvSpPr/>
           <p:nvPr/>
         </p:nvSpPr>
         <p:spPr>
           <a:xfrm>
-            <a:off x="2834640" y="3794760"/>
+            <a:off x="2834640" y="3657600"/>
             <a:ext cx="1554480" cy="1828800"/>
           </a:xfrm>
           <a:prstGeom prst="rect">
@@ -8853,13 +9269,13 @@
       </p:sp>
       <p:sp>
         <p:nvSpPr>
-          <p:cNvPr id="10" name="Text 8"/>
-          <p:cNvSpPr txBox="1"/>
-          <p:nvPr/>
-        </p:nvSpPr>
-        <p:spPr>
-          <a:xfrm>
-            <a:off x="2651760" y="3410712"/>
+          <p:cNvPr id="12" name="Text 10"/>
+          <p:cNvSpPr txBox="1"/>
+          <p:nvPr/>
+        </p:nvSpPr>
+        <p:spPr>
+          <a:xfrm>
+            <a:off x="2651760" y="3273552"/>
             <a:ext cx="1920240" cy="329184"/>
           </a:xfrm>
           <a:prstGeom prst="rect">
@@ -8892,14 +9308,14 @@
       </p:sp>
       <p:sp>
         <p:nvSpPr>
-          <p:cNvPr id="11" name="Text 9"/>
-          <p:cNvSpPr txBox="1"/>
-          <p:nvPr/>
-        </p:nvSpPr>
-        <p:spPr>
-          <a:xfrm>
-            <a:off x="2651760" y="5715000"/>
-            <a:ext cx="1920240" cy="685800"/>
+          <p:cNvPr id="13" name="Text 11"/>
+          <p:cNvSpPr txBox="1"/>
+          <p:nvPr/>
+        </p:nvSpPr>
+        <p:spPr>
+          <a:xfrm>
+            <a:off x="2651760" y="5577840"/>
+            <a:ext cx="1920240" cy="640080"/>
           </a:xfrm>
           <a:prstGeom prst="rect">
             <a:avLst/>
@@ -8974,13 +9390,13 @@
       </p:sp>
       <p:sp>
         <p:nvSpPr>
-          <p:cNvPr id="12" name="Shape 10"/>
+          <p:cNvPr id="14" name="Shape 12"/>
           <p:cNvSpPr/>
           <p:nvPr/>
         </p:nvSpPr>
         <p:spPr>
           <a:xfrm>
-            <a:off x="4846320" y="4846320"/>
+            <a:off x="4846320" y="4709160"/>
             <a:ext cx="1554480" cy="777240"/>
           </a:xfrm>
           <a:prstGeom prst="rect">
@@ -8994,13 +9410,13 @@
       </p:sp>
       <p:sp>
         <p:nvSpPr>
-          <p:cNvPr id="13" name="Text 11"/>
-          <p:cNvSpPr txBox="1"/>
-          <p:nvPr/>
-        </p:nvSpPr>
-        <p:spPr>
-          <a:xfrm>
-            <a:off x="4663440" y="4462272"/>
+          <p:cNvPr id="15" name="Text 13"/>
+          <p:cNvSpPr txBox="1"/>
+          <p:nvPr/>
+        </p:nvSpPr>
+        <p:spPr>
+          <a:xfrm>
+            <a:off x="4663440" y="4325112"/>
             <a:ext cx="1920240" cy="329184"/>
           </a:xfrm>
           <a:prstGeom prst="rect">
@@ -9033,14 +9449,14 @@
       </p:sp>
       <p:sp>
         <p:nvSpPr>
-          <p:cNvPr id="14" name="Text 12"/>
-          <p:cNvSpPr txBox="1"/>
-          <p:nvPr/>
-        </p:nvSpPr>
-        <p:spPr>
-          <a:xfrm>
-            <a:off x="4663440" y="5715000"/>
-            <a:ext cx="1920240" cy="685800"/>
+          <p:cNvPr id="16" name="Text 14"/>
+          <p:cNvSpPr txBox="1"/>
+          <p:nvPr/>
+        </p:nvSpPr>
+        <p:spPr>
+          <a:xfrm>
+            <a:off x="4663440" y="5577840"/>
+            <a:ext cx="1920240" cy="640080"/>
           </a:xfrm>
           <a:prstGeom prst="rect">
             <a:avLst/>
@@ -9115,7 +9531,7 @@
       </p:sp>
       <p:sp>
         <p:nvSpPr>
-          <p:cNvPr id="15" name="Shape 13"/>
+          <p:cNvPr id="17" name="Shape 15"/>
           <p:cNvSpPr/>
           <p:nvPr/>
         </p:nvSpPr>
@@ -9142,14 +9558,14 @@
       </p:sp>
       <p:sp>
         <p:nvSpPr>
-          <p:cNvPr id="16" name="Text 14"/>
-          <p:cNvSpPr txBox="1"/>
-          <p:nvPr/>
-        </p:nvSpPr>
-        <p:spPr>
-          <a:xfrm>
-            <a:off x="7498080" y="2606040"/>
-            <a:ext cx="3749040" cy="256032"/>
+          <p:cNvPr id="18" name="Text 16"/>
+          <p:cNvSpPr txBox="1"/>
+          <p:nvPr/>
+        </p:nvSpPr>
+        <p:spPr>
+          <a:xfrm>
+            <a:off x="7543800" y="2606040"/>
+            <a:ext cx="3685032" cy="256032"/>
           </a:xfrm>
           <a:prstGeom prst="rect">
             <a:avLst/>
@@ -9181,14 +9597,14 @@
       </p:sp>
       <p:sp>
         <p:nvSpPr>
-          <p:cNvPr id="17" name="Text 15"/>
-          <p:cNvSpPr txBox="1"/>
-          <p:nvPr/>
-        </p:nvSpPr>
-        <p:spPr>
-          <a:xfrm>
-            <a:off x="7498080" y="2971800"/>
-            <a:ext cx="3749040" cy="1417320"/>
+          <p:cNvPr id="19" name="Text 17"/>
+          <p:cNvSpPr txBox="1"/>
+          <p:nvPr/>
+        </p:nvSpPr>
+        <p:spPr>
+          <a:xfrm>
+            <a:off x="7543800" y="2971800"/>
+            <a:ext cx="3685032" cy="1417320"/>
           </a:xfrm>
           <a:prstGeom prst="rect">
             <a:avLst/>
@@ -9283,14 +9699,14 @@
       </p:sp>
       <p:sp>
         <p:nvSpPr>
-          <p:cNvPr id="18" name="Text 16"/>
-          <p:cNvSpPr txBox="1"/>
-          <p:nvPr/>
-        </p:nvSpPr>
-        <p:spPr>
-          <a:xfrm>
-            <a:off x="7498080" y="4572000"/>
-            <a:ext cx="3749040" cy="502920"/>
+          <p:cNvPr id="20" name="Text 18"/>
+          <p:cNvSpPr txBox="1"/>
+          <p:nvPr/>
+        </p:nvSpPr>
+        <p:spPr>
+          <a:xfrm>
+            <a:off x="7543800" y="4572000"/>
+            <a:ext cx="3685032" cy="502920"/>
           </a:xfrm>
           <a:prstGeom prst="rect">
             <a:avLst/>
@@ -9325,14 +9741,14 @@
       </p:sp>
       <p:sp>
         <p:nvSpPr>
-          <p:cNvPr id="19" name="Text 17"/>
-          <p:cNvSpPr txBox="1"/>
-          <p:nvPr/>
-        </p:nvSpPr>
-        <p:spPr>
-          <a:xfrm>
-            <a:off x="7498080" y="5285232"/>
-            <a:ext cx="3749040" cy="274320"/>
+          <p:cNvPr id="21" name="Text 19"/>
+          <p:cNvSpPr txBox="1"/>
+          <p:nvPr/>
+        </p:nvSpPr>
+        <p:spPr>
+          <a:xfrm>
+            <a:off x="7543800" y="5330952"/>
+            <a:ext cx="3685032" cy="274320"/>
           </a:xfrm>
           <a:prstGeom prst="rect">
             <a:avLst/>
@@ -9477,14 +9893,66 @@
       </p:sp>
       <p:sp>
         <p:nvSpPr>
-          <p:cNvPr id="4" name="Text 2"/>
-          <p:cNvSpPr txBox="1"/>
-          <p:nvPr/>
-        </p:nvSpPr>
-        <p:spPr>
-          <a:xfrm>
-            <a:off x="640080" y="6510528"/>
-            <a:ext cx="3657600" cy="237744"/>
+          <p:cNvPr id="4" name="Shape 2"/>
+          <p:cNvSpPr/>
+          <p:nvPr/>
+        </p:nvSpPr>
+        <p:spPr>
+          <a:xfrm>
+            <a:off x="640080" y="6382512"/>
+            <a:ext cx="274320" cy="274320"/>
+          </a:xfrm>
+          <a:prstGeom prst="roundRect">
+            <a:avLst>
+              <a:gd name="adj" fmla="val 21800"/>
+            </a:avLst>
+          </a:prstGeom>
+          <a:solidFill>
+            <a:srgbClr val="3ECFA0"/>
+          </a:solidFill>
+          <a:ln w="12700">
+            <a:solidFill>
+              <a:srgbClr val="3ECFA0"/>
+            </a:solidFill>
+            <a:prstDash val="solid"/>
+          </a:ln>
+        </p:spPr>
+      </p:sp>
+      <p:sp>
+        <p:nvSpPr>
+          <p:cNvPr id="5" name="Shape 3"/>
+          <p:cNvSpPr/>
+          <p:nvPr/>
+        </p:nvSpPr>
+        <p:spPr>
+          <a:xfrm>
+            <a:off x="717438" y="6459870"/>
+            <a:ext cx="119604" cy="119604"/>
+          </a:xfrm>
+          <a:prstGeom prst="ellipse">
+            <a:avLst/>
+          </a:prstGeom>
+          <a:solidFill>
+            <a:srgbClr val="3ECFA0"/>
+          </a:solidFill>
+          <a:ln w="13868">
+            <a:solidFill>
+              <a:srgbClr val="0B1A19"/>
+            </a:solidFill>
+            <a:prstDash val="solid"/>
+          </a:ln>
+        </p:spPr>
+      </p:sp>
+      <p:sp>
+        <p:nvSpPr>
+          <p:cNvPr id="6" name="Text 4"/>
+          <p:cNvSpPr txBox="1"/>
+          <p:nvPr/>
+        </p:nvSpPr>
+        <p:spPr>
+          <a:xfrm>
+            <a:off x="1005840" y="6400800"/>
+            <a:ext cx="3291840" cy="237744"/>
           </a:xfrm>
           <a:prstGeom prst="rect">
             <a:avLst/>
@@ -9516,13 +9984,13 @@
       </p:sp>
       <p:sp>
         <p:nvSpPr>
-          <p:cNvPr id="5" name="Text 3"/>
-          <p:cNvSpPr txBox="1"/>
-          <p:nvPr/>
-        </p:nvSpPr>
-        <p:spPr>
-          <a:xfrm>
-            <a:off x="7434072" y="6510528"/>
+          <p:cNvPr id="7" name="Text 5"/>
+          <p:cNvSpPr txBox="1"/>
+          <p:nvPr/>
+        </p:nvSpPr>
+        <p:spPr>
+          <a:xfrm>
+            <a:off x="7434072" y="6400800"/>
             <a:ext cx="4114800" cy="237744"/>
           </a:xfrm>
           <a:prstGeom prst="rect">
@@ -9555,14 +10023,14 @@
       </p:sp>
       <p:sp>
         <p:nvSpPr>
-          <p:cNvPr id="6" name="Shape 4"/>
+          <p:cNvPr id="8" name="Shape 6"/>
           <p:cNvSpPr/>
           <p:nvPr/>
         </p:nvSpPr>
         <p:spPr>
           <a:xfrm>
             <a:off x="640080" y="2212848"/>
-            <a:ext cx="3127248" cy="1810512"/>
+            <a:ext cx="3386023" cy="1810512"/>
           </a:xfrm>
           <a:prstGeom prst="roundRect">
             <a:avLst>
@@ -9582,7 +10050,7 @@
       </p:sp>
       <p:sp>
         <p:nvSpPr>
-          <p:cNvPr id="7" name="Shape 5"/>
+          <p:cNvPr id="9" name="Shape 7"/>
           <p:cNvSpPr/>
           <p:nvPr/>
         </p:nvSpPr>
@@ -9607,7 +10075,7 @@
       </p:sp>
       <p:pic>
         <p:nvPicPr>
-          <p:cNvPr id="8" name="Image 0" descr="preencoded.png">    </p:cNvPr>
+          <p:cNvPr id="10" name="Image 0" descr="preencoded.png">    </p:cNvPr>
           <p:cNvPicPr>
             <a:picLocks noChangeAspect="1"/>
           </p:cNvPicPr>
@@ -9631,14 +10099,14 @@
       </p:pic>
       <p:sp>
         <p:nvSpPr>
-          <p:cNvPr id="9" name="Text 6"/>
+          <p:cNvPr id="11" name="Text 8"/>
           <p:cNvSpPr txBox="1"/>
           <p:nvPr/>
         </p:nvSpPr>
         <p:spPr>
           <a:xfrm>
             <a:off x="1572768" y="2523744"/>
-            <a:ext cx="2029968" cy="237744"/>
+            <a:ext cx="2197303" cy="237744"/>
           </a:xfrm>
           <a:prstGeom prst="rect">
             <a:avLst/>
@@ -9670,14 +10138,14 @@
       </p:sp>
       <p:sp>
         <p:nvSpPr>
-          <p:cNvPr id="10" name="Text 7"/>
+          <p:cNvPr id="12" name="Text 9"/>
           <p:cNvSpPr txBox="1"/>
           <p:nvPr/>
         </p:nvSpPr>
         <p:spPr>
           <a:xfrm>
             <a:off x="1572768" y="2743200"/>
-            <a:ext cx="2029968" cy="566928"/>
+            <a:ext cx="2197303" cy="566928"/>
           </a:xfrm>
           <a:prstGeom prst="rect">
             <a:avLst/>
@@ -9709,14 +10177,14 @@
       </p:sp>
       <p:sp>
         <p:nvSpPr>
-          <p:cNvPr id="11" name="Text 8"/>
+          <p:cNvPr id="13" name="Text 10"/>
           <p:cNvSpPr txBox="1"/>
           <p:nvPr/>
         </p:nvSpPr>
         <p:spPr>
           <a:xfrm>
             <a:off x="896112" y="3511296"/>
-            <a:ext cx="2615184" cy="329184"/>
+            <a:ext cx="2873959" cy="329184"/>
           </a:xfrm>
           <a:prstGeom prst="rect">
             <a:avLst/>
@@ -9748,14 +10216,14 @@
       </p:sp>
       <p:sp>
         <p:nvSpPr>
-          <p:cNvPr id="12" name="Shape 9"/>
+          <p:cNvPr id="14" name="Shape 11"/>
           <p:cNvSpPr/>
           <p:nvPr/>
         </p:nvSpPr>
         <p:spPr>
           <a:xfrm>
-            <a:off x="4142232" y="2212848"/>
-            <a:ext cx="3127248" cy="1810512"/>
+            <a:off x="4401007" y="2212848"/>
+            <a:ext cx="3386023" cy="1810512"/>
           </a:xfrm>
           <a:prstGeom prst="roundRect">
             <a:avLst>
@@ -9775,13 +10243,13 @@
       </p:sp>
       <p:sp>
         <p:nvSpPr>
-          <p:cNvPr id="13" name="Shape 10"/>
+          <p:cNvPr id="15" name="Shape 12"/>
           <p:cNvSpPr/>
           <p:nvPr/>
         </p:nvSpPr>
         <p:spPr>
           <a:xfrm>
-            <a:off x="4398264" y="2487168"/>
+            <a:off x="4657039" y="2487168"/>
             <a:ext cx="548640" cy="548640"/>
           </a:xfrm>
           <a:prstGeom prst="ellipse">
@@ -9800,7 +10268,7 @@
       </p:sp>
       <p:pic>
         <p:nvPicPr>
-          <p:cNvPr id="14" name="Image 1" descr="preencoded.png">    </p:cNvPr>
+          <p:cNvPr id="16" name="Image 1" descr="preencoded.png">    </p:cNvPr>
           <p:cNvPicPr>
             <a:picLocks noChangeAspect="1"/>
           </p:cNvPicPr>
@@ -9814,7 +10282,7 @@
         </p:blipFill>
         <p:spPr>
           <a:xfrm>
-            <a:off x="4539539" y="2628443"/>
+            <a:off x="4798314" y="2628443"/>
             <a:ext cx="266090" cy="266090"/>
           </a:xfrm>
           <a:prstGeom prst="rect">
@@ -9824,14 +10292,14 @@
       </p:pic>
       <p:sp>
         <p:nvSpPr>
-          <p:cNvPr id="15" name="Text 11"/>
-          <p:cNvSpPr txBox="1"/>
-          <p:nvPr/>
-        </p:nvSpPr>
-        <p:spPr>
-          <a:xfrm>
-            <a:off x="5074920" y="2523744"/>
-            <a:ext cx="2029968" cy="237744"/>
+          <p:cNvPr id="17" name="Text 13"/>
+          <p:cNvSpPr txBox="1"/>
+          <p:nvPr/>
+        </p:nvSpPr>
+        <p:spPr>
+          <a:xfrm>
+            <a:off x="5333695" y="2523744"/>
+            <a:ext cx="2197303" cy="237744"/>
           </a:xfrm>
           <a:prstGeom prst="rect">
             <a:avLst/>
@@ -9863,14 +10331,14 @@
       </p:sp>
       <p:sp>
         <p:nvSpPr>
-          <p:cNvPr id="16" name="Text 12"/>
-          <p:cNvSpPr txBox="1"/>
-          <p:nvPr/>
-        </p:nvSpPr>
-        <p:spPr>
-          <a:xfrm>
-            <a:off x="5074920" y="2743200"/>
-            <a:ext cx="2029968" cy="566928"/>
+          <p:cNvPr id="18" name="Text 14"/>
+          <p:cNvSpPr txBox="1"/>
+          <p:nvPr/>
+        </p:nvSpPr>
+        <p:spPr>
+          <a:xfrm>
+            <a:off x="5333695" y="2743200"/>
+            <a:ext cx="2197303" cy="566928"/>
           </a:xfrm>
           <a:prstGeom prst="rect">
             <a:avLst/>
@@ -9902,14 +10370,14 @@
       </p:sp>
       <p:sp>
         <p:nvSpPr>
-          <p:cNvPr id="17" name="Text 13"/>
-          <p:cNvSpPr txBox="1"/>
-          <p:nvPr/>
-        </p:nvSpPr>
-        <p:spPr>
-          <a:xfrm>
-            <a:off x="4398264" y="3511296"/>
-            <a:ext cx="2615184" cy="329184"/>
+          <p:cNvPr id="19" name="Text 15"/>
+          <p:cNvSpPr txBox="1"/>
+          <p:nvPr/>
+        </p:nvSpPr>
+        <p:spPr>
+          <a:xfrm>
+            <a:off x="4657039" y="3511296"/>
+            <a:ext cx="2873959" cy="329184"/>
           </a:xfrm>
           <a:prstGeom prst="rect">
             <a:avLst/>
@@ -9941,14 +10409,14 @@
       </p:sp>
       <p:sp>
         <p:nvSpPr>
-          <p:cNvPr id="18" name="Shape 14"/>
+          <p:cNvPr id="20" name="Shape 16"/>
           <p:cNvSpPr/>
           <p:nvPr/>
         </p:nvSpPr>
         <p:spPr>
           <a:xfrm>
-            <a:off x="7644384" y="2212848"/>
-            <a:ext cx="3127248" cy="1810512"/>
+            <a:off x="8161934" y="2212848"/>
+            <a:ext cx="3386023" cy="1810512"/>
           </a:xfrm>
           <a:prstGeom prst="roundRect">
             <a:avLst>
@@ -9968,13 +10436,13 @@
       </p:sp>
       <p:sp>
         <p:nvSpPr>
-          <p:cNvPr id="19" name="Shape 15"/>
+          <p:cNvPr id="21" name="Shape 17"/>
           <p:cNvSpPr/>
           <p:nvPr/>
         </p:nvSpPr>
         <p:spPr>
           <a:xfrm>
-            <a:off x="7900416" y="2487168"/>
+            <a:off x="8417966" y="2487168"/>
             <a:ext cx="548640" cy="548640"/>
           </a:xfrm>
           <a:prstGeom prst="ellipse">
@@ -9993,7 +10461,7 @@
       </p:sp>
       <p:pic>
         <p:nvPicPr>
-          <p:cNvPr id="20" name="Image 2" descr="preencoded.png">    </p:cNvPr>
+          <p:cNvPr id="22" name="Image 2" descr="preencoded.png">    </p:cNvPr>
           <p:cNvPicPr>
             <a:picLocks noChangeAspect="1"/>
           </p:cNvPicPr>
@@ -10007,7 +10475,7 @@
         </p:blipFill>
         <p:spPr>
           <a:xfrm>
-            <a:off x="8041691" y="2628443"/>
+            <a:off x="8559241" y="2628443"/>
             <a:ext cx="266090" cy="266090"/>
           </a:xfrm>
           <a:prstGeom prst="rect">
@@ -10017,14 +10485,14 @@
       </p:pic>
       <p:sp>
         <p:nvSpPr>
-          <p:cNvPr id="21" name="Text 16"/>
-          <p:cNvSpPr txBox="1"/>
-          <p:nvPr/>
-        </p:nvSpPr>
-        <p:spPr>
-          <a:xfrm>
-            <a:off x="8577072" y="2523744"/>
-            <a:ext cx="2029968" cy="237744"/>
+          <p:cNvPr id="23" name="Text 18"/>
+          <p:cNvSpPr txBox="1"/>
+          <p:nvPr/>
+        </p:nvSpPr>
+        <p:spPr>
+          <a:xfrm>
+            <a:off x="9094622" y="2523744"/>
+            <a:ext cx="2197303" cy="237744"/>
           </a:xfrm>
           <a:prstGeom prst="rect">
             <a:avLst/>
@@ -10056,14 +10524,14 @@
       </p:sp>
       <p:sp>
         <p:nvSpPr>
-          <p:cNvPr id="22" name="Text 17"/>
-          <p:cNvSpPr txBox="1"/>
-          <p:nvPr/>
-        </p:nvSpPr>
-        <p:spPr>
-          <a:xfrm>
-            <a:off x="8577072" y="2743200"/>
-            <a:ext cx="2029968" cy="566928"/>
+          <p:cNvPr id="24" name="Text 19"/>
+          <p:cNvSpPr txBox="1"/>
+          <p:nvPr/>
+        </p:nvSpPr>
+        <p:spPr>
+          <a:xfrm>
+            <a:off x="9094622" y="2743200"/>
+            <a:ext cx="2197303" cy="566928"/>
           </a:xfrm>
           <a:prstGeom prst="rect">
             <a:avLst/>
@@ -10095,14 +10563,14 @@
       </p:sp>
       <p:sp>
         <p:nvSpPr>
-          <p:cNvPr id="23" name="Text 18"/>
-          <p:cNvSpPr txBox="1"/>
-          <p:nvPr/>
-        </p:nvSpPr>
-        <p:spPr>
-          <a:xfrm>
-            <a:off x="7900416" y="3511296"/>
-            <a:ext cx="2615184" cy="329184"/>
+          <p:cNvPr id="25" name="Text 20"/>
+          <p:cNvSpPr txBox="1"/>
+          <p:nvPr/>
+        </p:nvSpPr>
+        <p:spPr>
+          <a:xfrm>
+            <a:off x="8417966" y="3511296"/>
+            <a:ext cx="2873959" cy="329184"/>
           </a:xfrm>
           <a:prstGeom prst="rect">
             <a:avLst/>
@@ -10134,13 +10602,13 @@
       </p:sp>
       <p:sp>
         <p:nvSpPr>
-          <p:cNvPr id="24" name="Text 19"/>
-          <p:cNvSpPr txBox="1"/>
-          <p:nvPr/>
-        </p:nvSpPr>
-        <p:spPr>
-          <a:xfrm>
-            <a:off x="3776472" y="2898648"/>
+          <p:cNvPr id="26" name="Text 21"/>
+          <p:cNvSpPr txBox="1"/>
+          <p:nvPr/>
+        </p:nvSpPr>
+        <p:spPr>
+          <a:xfrm>
+            <a:off x="4030675" y="2898648"/>
             <a:ext cx="365760" cy="411480"/>
           </a:xfrm>
           <a:prstGeom prst="rect">
@@ -10173,13 +10641,13 @@
       </p:sp>
       <p:sp>
         <p:nvSpPr>
-          <p:cNvPr id="25" name="Text 20"/>
-          <p:cNvSpPr txBox="1"/>
-          <p:nvPr/>
-        </p:nvSpPr>
-        <p:spPr>
-          <a:xfrm>
-            <a:off x="7278624" y="2898648"/>
+          <p:cNvPr id="27" name="Text 22"/>
+          <p:cNvSpPr txBox="1"/>
+          <p:nvPr/>
+        </p:nvSpPr>
+        <p:spPr>
+          <a:xfrm>
+            <a:off x="7791602" y="2898648"/>
             <a:ext cx="365760" cy="411480"/>
           </a:xfrm>
           <a:prstGeom prst="rect">
@@ -10212,7 +10680,7 @@
       </p:sp>
       <p:sp>
         <p:nvSpPr>
-          <p:cNvPr id="26" name="Shape 21"/>
+          <p:cNvPr id="28" name="Shape 23"/>
           <p:cNvSpPr/>
           <p:nvPr/>
         </p:nvSpPr>
@@ -10234,13 +10702,13 @@
       </p:sp>
       <p:sp>
         <p:nvSpPr>
-          <p:cNvPr id="27" name="Text 22"/>
-          <p:cNvSpPr txBox="1"/>
-          <p:nvPr/>
-        </p:nvSpPr>
-        <p:spPr>
-          <a:xfrm>
-            <a:off x="1005840" y="4645152"/>
+          <p:cNvPr id="29" name="Text 24"/>
+          <p:cNvSpPr txBox="1"/>
+          <p:nvPr/>
+        </p:nvSpPr>
+        <p:spPr>
+          <a:xfrm>
+            <a:off x="960120" y="4645152"/>
             <a:ext cx="2286000" cy="1051560"/>
           </a:xfrm>
           <a:prstGeom prst="rect">
@@ -10273,7 +10741,7 @@
       </p:sp>
       <p:sp>
         <p:nvSpPr>
-          <p:cNvPr id="28" name="Text 23"/>
+          <p:cNvPr id="30" name="Text 25"/>
           <p:cNvSpPr txBox="1"/>
           <p:nvPr/>
         </p:nvSpPr>
@@ -10335,7 +10803,7 @@
       </p:sp>
       <p:sp>
         <p:nvSpPr>
-          <p:cNvPr id="29" name="Shape 24"/>
+          <p:cNvPr id="31" name="Shape 26"/>
           <p:cNvSpPr/>
           <p:nvPr/>
         </p:nvSpPr>
@@ -10362,14 +10830,14 @@
       </p:sp>
       <p:sp>
         <p:nvSpPr>
-          <p:cNvPr id="30" name="Text 25"/>
+          <p:cNvPr id="32" name="Text 27"/>
           <p:cNvSpPr txBox="1"/>
           <p:nvPr/>
         </p:nvSpPr>
         <p:spPr>
           <a:xfrm>
             <a:off x="8001000" y="4773168"/>
-            <a:ext cx="3291840" cy="822960"/>
+            <a:ext cx="3227832" cy="822960"/>
           </a:xfrm>
           <a:prstGeom prst="rect">
             <a:avLst/>
@@ -10571,14 +11039,66 @@
       </p:sp>
       <p:sp>
         <p:nvSpPr>
-          <p:cNvPr id="4" name="Text 2"/>
-          <p:cNvSpPr txBox="1"/>
-          <p:nvPr/>
-        </p:nvSpPr>
-        <p:spPr>
-          <a:xfrm>
-            <a:off x="640080" y="6510528"/>
-            <a:ext cx="3657600" cy="237744"/>
+          <p:cNvPr id="4" name="Shape 2"/>
+          <p:cNvSpPr/>
+          <p:nvPr/>
+        </p:nvSpPr>
+        <p:spPr>
+          <a:xfrm>
+            <a:off x="640080" y="6382512"/>
+            <a:ext cx="274320" cy="274320"/>
+          </a:xfrm>
+          <a:prstGeom prst="roundRect">
+            <a:avLst>
+              <a:gd name="adj" fmla="val 21800"/>
+            </a:avLst>
+          </a:prstGeom>
+          <a:solidFill>
+            <a:srgbClr val="3ECFA0"/>
+          </a:solidFill>
+          <a:ln w="12700">
+            <a:solidFill>
+              <a:srgbClr val="3ECFA0"/>
+            </a:solidFill>
+            <a:prstDash val="solid"/>
+          </a:ln>
+        </p:spPr>
+      </p:sp>
+      <p:sp>
+        <p:nvSpPr>
+          <p:cNvPr id="5" name="Shape 3"/>
+          <p:cNvSpPr/>
+          <p:nvPr/>
+        </p:nvSpPr>
+        <p:spPr>
+          <a:xfrm>
+            <a:off x="717438" y="6459870"/>
+            <a:ext cx="119604" cy="119604"/>
+          </a:xfrm>
+          <a:prstGeom prst="ellipse">
+            <a:avLst/>
+          </a:prstGeom>
+          <a:solidFill>
+            <a:srgbClr val="3ECFA0"/>
+          </a:solidFill>
+          <a:ln w="13868">
+            <a:solidFill>
+              <a:srgbClr val="0B1A19"/>
+            </a:solidFill>
+            <a:prstDash val="solid"/>
+          </a:ln>
+        </p:spPr>
+      </p:sp>
+      <p:sp>
+        <p:nvSpPr>
+          <p:cNvPr id="6" name="Text 4"/>
+          <p:cNvSpPr txBox="1"/>
+          <p:nvPr/>
+        </p:nvSpPr>
+        <p:spPr>
+          <a:xfrm>
+            <a:off x="1005840" y="6400800"/>
+            <a:ext cx="3291840" cy="237744"/>
           </a:xfrm>
           <a:prstGeom prst="rect">
             <a:avLst/>
@@ -10610,13 +11130,13 @@
       </p:sp>
       <p:sp>
         <p:nvSpPr>
-          <p:cNvPr id="5" name="Text 3"/>
-          <p:cNvSpPr txBox="1"/>
-          <p:nvPr/>
-        </p:nvSpPr>
-        <p:spPr>
-          <a:xfrm>
-            <a:off x="7434072" y="6510528"/>
+          <p:cNvPr id="7" name="Text 5"/>
+          <p:cNvSpPr txBox="1"/>
+          <p:nvPr/>
+        </p:nvSpPr>
+        <p:spPr>
+          <a:xfrm>
+            <a:off x="7434072" y="6400800"/>
             <a:ext cx="4114800" cy="237744"/>
           </a:xfrm>
           <a:prstGeom prst="rect">
@@ -10649,7 +11169,7 @@
       </p:sp>
       <p:sp>
         <p:nvSpPr>
-          <p:cNvPr id="6" name="Text 4"/>
+          <p:cNvPr id="8" name="Text 6"/>
           <p:cNvSpPr txBox="1"/>
           <p:nvPr/>
         </p:nvSpPr>
@@ -10688,7 +11208,7 @@
       </p:sp>
       <p:graphicFrame>
         <p:nvGraphicFramePr>
-          <p:cNvPr id="7" name="Chart 0" descr=""/>
+          <p:cNvPr id="9" name="Chart 0" descr=""/>
           <p:cNvGraphicFramePr/>
           <p:nvPr/>
         </p:nvGraphicFramePr>
@@ -10704,7 +11224,7 @@
       </p:graphicFrame>
       <p:sp>
         <p:nvSpPr>
-          <p:cNvPr id="8" name="Shape 5"/>
+          <p:cNvPr id="10" name="Shape 7"/>
           <p:cNvSpPr/>
           <p:nvPr/>
         </p:nvSpPr>
@@ -10731,14 +11251,14 @@
       </p:sp>
       <p:sp>
         <p:nvSpPr>
-          <p:cNvPr id="9" name="Text 6"/>
+          <p:cNvPr id="11" name="Text 8"/>
           <p:cNvSpPr txBox="1"/>
           <p:nvPr/>
         </p:nvSpPr>
         <p:spPr>
           <a:xfrm>
             <a:off x="7973568" y="2670048"/>
-            <a:ext cx="3291840" cy="502920"/>
+            <a:ext cx="3236976" cy="502920"/>
           </a:xfrm>
           <a:prstGeom prst="rect">
             <a:avLst/>
@@ -10770,14 +11290,14 @@
       </p:sp>
       <p:sp>
         <p:nvSpPr>
-          <p:cNvPr id="10" name="Text 7"/>
+          <p:cNvPr id="12" name="Text 9"/>
           <p:cNvSpPr txBox="1"/>
           <p:nvPr/>
         </p:nvSpPr>
         <p:spPr>
           <a:xfrm>
             <a:off x="7973568" y="3172968"/>
-            <a:ext cx="3291840" cy="292608"/>
+            <a:ext cx="3236976" cy="292608"/>
           </a:xfrm>
           <a:prstGeom prst="rect">
             <a:avLst/>
@@ -10809,14 +11329,14 @@
       </p:sp>
       <p:sp>
         <p:nvSpPr>
-          <p:cNvPr id="11" name="Text 8"/>
+          <p:cNvPr id="13" name="Text 10"/>
           <p:cNvSpPr txBox="1"/>
           <p:nvPr/>
         </p:nvSpPr>
         <p:spPr>
           <a:xfrm>
             <a:off x="7973568" y="3840480"/>
-            <a:ext cx="3291840" cy="502920"/>
+            <a:ext cx="3236976" cy="502920"/>
           </a:xfrm>
           <a:prstGeom prst="rect">
             <a:avLst/>
@@ -10848,14 +11368,14 @@
       </p:sp>
       <p:sp>
         <p:nvSpPr>
-          <p:cNvPr id="12" name="Text 9"/>
+          <p:cNvPr id="14" name="Text 11"/>
           <p:cNvSpPr txBox="1"/>
           <p:nvPr/>
         </p:nvSpPr>
         <p:spPr>
           <a:xfrm>
             <a:off x="7973568" y="4343400"/>
-            <a:ext cx="3291840" cy="292608"/>
+            <a:ext cx="3236976" cy="292608"/>
           </a:xfrm>
           <a:prstGeom prst="rect">
             <a:avLst/>
@@ -10887,14 +11407,14 @@
       </p:sp>
       <p:sp>
         <p:nvSpPr>
-          <p:cNvPr id="13" name="Text 10"/>
+          <p:cNvPr id="15" name="Text 12"/>
           <p:cNvSpPr txBox="1"/>
           <p:nvPr/>
         </p:nvSpPr>
         <p:spPr>
           <a:xfrm>
             <a:off x="7973568" y="5010912"/>
-            <a:ext cx="3291840" cy="502920"/>
+            <a:ext cx="3236976" cy="502920"/>
           </a:xfrm>
           <a:prstGeom prst="rect">
             <a:avLst/>
@@ -10926,14 +11446,14 @@
       </p:sp>
       <p:sp>
         <p:nvSpPr>
-          <p:cNvPr id="14" name="Text 11"/>
+          <p:cNvPr id="16" name="Text 13"/>
           <p:cNvSpPr txBox="1"/>
           <p:nvPr/>
         </p:nvSpPr>
         <p:spPr>
           <a:xfrm>
             <a:off x="7973568" y="5513832"/>
-            <a:ext cx="3291840" cy="292608"/>
+            <a:ext cx="3236976" cy="292608"/>
           </a:xfrm>
           <a:prstGeom prst="rect">
             <a:avLst/>
@@ -11078,14 +11598,66 @@
       </p:sp>
       <p:sp>
         <p:nvSpPr>
-          <p:cNvPr id="4" name="Text 2"/>
-          <p:cNvSpPr txBox="1"/>
-          <p:nvPr/>
-        </p:nvSpPr>
-        <p:spPr>
-          <a:xfrm>
-            <a:off x="640080" y="6510528"/>
-            <a:ext cx="3657600" cy="237744"/>
+          <p:cNvPr id="4" name="Shape 2"/>
+          <p:cNvSpPr/>
+          <p:nvPr/>
+        </p:nvSpPr>
+        <p:spPr>
+          <a:xfrm>
+            <a:off x="640080" y="6382512"/>
+            <a:ext cx="274320" cy="274320"/>
+          </a:xfrm>
+          <a:prstGeom prst="roundRect">
+            <a:avLst>
+              <a:gd name="adj" fmla="val 21800"/>
+            </a:avLst>
+          </a:prstGeom>
+          <a:solidFill>
+            <a:srgbClr val="3ECFA0"/>
+          </a:solidFill>
+          <a:ln w="12700">
+            <a:solidFill>
+              <a:srgbClr val="3ECFA0"/>
+            </a:solidFill>
+            <a:prstDash val="solid"/>
+          </a:ln>
+        </p:spPr>
+      </p:sp>
+      <p:sp>
+        <p:nvSpPr>
+          <p:cNvPr id="5" name="Shape 3"/>
+          <p:cNvSpPr/>
+          <p:nvPr/>
+        </p:nvSpPr>
+        <p:spPr>
+          <a:xfrm>
+            <a:off x="717438" y="6459870"/>
+            <a:ext cx="119604" cy="119604"/>
+          </a:xfrm>
+          <a:prstGeom prst="ellipse">
+            <a:avLst/>
+          </a:prstGeom>
+          <a:solidFill>
+            <a:srgbClr val="3ECFA0"/>
+          </a:solidFill>
+          <a:ln w="13868">
+            <a:solidFill>
+              <a:srgbClr val="0B1A19"/>
+            </a:solidFill>
+            <a:prstDash val="solid"/>
+          </a:ln>
+        </p:spPr>
+      </p:sp>
+      <p:sp>
+        <p:nvSpPr>
+          <p:cNvPr id="6" name="Text 4"/>
+          <p:cNvSpPr txBox="1"/>
+          <p:nvPr/>
+        </p:nvSpPr>
+        <p:spPr>
+          <a:xfrm>
+            <a:off x="1005840" y="6400800"/>
+            <a:ext cx="3291840" cy="237744"/>
           </a:xfrm>
           <a:prstGeom prst="rect">
             <a:avLst/>
@@ -11117,13 +11689,13 @@
       </p:sp>
       <p:sp>
         <p:nvSpPr>
-          <p:cNvPr id="5" name="Text 3"/>
-          <p:cNvSpPr txBox="1"/>
-          <p:nvPr/>
-        </p:nvSpPr>
-        <p:spPr>
-          <a:xfrm>
-            <a:off x="7434072" y="6510528"/>
+          <p:cNvPr id="7" name="Text 5"/>
+          <p:cNvSpPr txBox="1"/>
+          <p:nvPr/>
+        </p:nvSpPr>
+        <p:spPr>
+          <a:xfrm>
+            <a:off x="7434072" y="6400800"/>
             <a:ext cx="4114800" cy="237744"/>
           </a:xfrm>
           <a:prstGeom prst="rect">
@@ -12273,7 +12845,7 @@
       </p:graphicFrame>
       <p:sp>
         <p:nvSpPr>
-          <p:cNvPr id="7" name="Shape 4"/>
+          <p:cNvPr id="9" name="Shape 6"/>
           <p:cNvSpPr/>
           <p:nvPr/>
         </p:nvSpPr>
@@ -12298,7 +12870,7 @@
       </p:sp>
       <p:pic>
         <p:nvPicPr>
-          <p:cNvPr id="8" name="Image 0" descr="preencoded.png">    </p:cNvPr>
+          <p:cNvPr id="10" name="Image 0" descr="preencoded.png">    </p:cNvPr>
           <p:cNvPicPr>
             <a:picLocks noChangeAspect="1"/>
           </p:cNvPicPr>
@@ -12322,14 +12894,14 @@
       </p:pic>
       <p:sp>
         <p:nvSpPr>
-          <p:cNvPr id="9" name="Text 5"/>
+          <p:cNvPr id="11" name="Text 7"/>
           <p:cNvSpPr txBox="1"/>
           <p:nvPr/>
         </p:nvSpPr>
         <p:spPr>
           <a:xfrm>
             <a:off x="1481328" y="5248656"/>
-            <a:ext cx="9418320" cy="548640"/>
+            <a:ext cx="10067544" cy="548640"/>
           </a:xfrm>
           <a:prstGeom prst="rect">
             <a:avLst/>
@@ -12494,14 +13066,66 @@
       </p:sp>
       <p:sp>
         <p:nvSpPr>
-          <p:cNvPr id="4" name="Text 2"/>
-          <p:cNvSpPr txBox="1"/>
-          <p:nvPr/>
-        </p:nvSpPr>
-        <p:spPr>
-          <a:xfrm>
-            <a:off x="640080" y="6510528"/>
-            <a:ext cx="3657600" cy="237744"/>
+          <p:cNvPr id="4" name="Shape 2"/>
+          <p:cNvSpPr/>
+          <p:nvPr/>
+        </p:nvSpPr>
+        <p:spPr>
+          <a:xfrm>
+            <a:off x="640080" y="6382512"/>
+            <a:ext cx="274320" cy="274320"/>
+          </a:xfrm>
+          <a:prstGeom prst="roundRect">
+            <a:avLst>
+              <a:gd name="adj" fmla="val 21800"/>
+            </a:avLst>
+          </a:prstGeom>
+          <a:solidFill>
+            <a:srgbClr val="3ECFA0"/>
+          </a:solidFill>
+          <a:ln w="12700">
+            <a:solidFill>
+              <a:srgbClr val="3ECFA0"/>
+            </a:solidFill>
+            <a:prstDash val="solid"/>
+          </a:ln>
+        </p:spPr>
+      </p:sp>
+      <p:sp>
+        <p:nvSpPr>
+          <p:cNvPr id="5" name="Shape 3"/>
+          <p:cNvSpPr/>
+          <p:nvPr/>
+        </p:nvSpPr>
+        <p:spPr>
+          <a:xfrm>
+            <a:off x="717438" y="6459870"/>
+            <a:ext cx="119604" cy="119604"/>
+          </a:xfrm>
+          <a:prstGeom prst="ellipse">
+            <a:avLst/>
+          </a:prstGeom>
+          <a:solidFill>
+            <a:srgbClr val="3ECFA0"/>
+          </a:solidFill>
+          <a:ln w="13868">
+            <a:solidFill>
+              <a:srgbClr val="0B1A19"/>
+            </a:solidFill>
+            <a:prstDash val="solid"/>
+          </a:ln>
+        </p:spPr>
+      </p:sp>
+      <p:sp>
+        <p:nvSpPr>
+          <p:cNvPr id="6" name="Text 4"/>
+          <p:cNvSpPr txBox="1"/>
+          <p:nvPr/>
+        </p:nvSpPr>
+        <p:spPr>
+          <a:xfrm>
+            <a:off x="1005840" y="6400800"/>
+            <a:ext cx="3291840" cy="237744"/>
           </a:xfrm>
           <a:prstGeom prst="rect">
             <a:avLst/>
@@ -12533,13 +13157,13 @@
       </p:sp>
       <p:sp>
         <p:nvSpPr>
-          <p:cNvPr id="5" name="Text 3"/>
-          <p:cNvSpPr txBox="1"/>
-          <p:nvPr/>
-        </p:nvSpPr>
-        <p:spPr>
-          <a:xfrm>
-            <a:off x="7434072" y="6510528"/>
+          <p:cNvPr id="7" name="Text 5"/>
+          <p:cNvSpPr txBox="1"/>
+          <p:nvPr/>
+        </p:nvSpPr>
+        <p:spPr>
+          <a:xfrm>
+            <a:off x="7434072" y="6400800"/>
             <a:ext cx="4114800" cy="237744"/>
           </a:xfrm>
           <a:prstGeom prst="rect">
@@ -12572,7 +13196,7 @@
       </p:sp>
       <p:sp>
         <p:nvSpPr>
-          <p:cNvPr id="6" name="Shape 4"/>
+          <p:cNvPr id="8" name="Shape 6"/>
           <p:cNvSpPr/>
           <p:nvPr/>
         </p:nvSpPr>
@@ -12597,7 +13221,7 @@
       </p:sp>
       <p:pic>
         <p:nvPicPr>
-          <p:cNvPr id="7" name="Image 0" descr="preencoded.png">    </p:cNvPr>
+          <p:cNvPr id="9" name="Image 0" descr="preencoded.png">    </p:cNvPr>
           <p:cNvPicPr>
             <a:picLocks noChangeAspect="1"/>
           </p:cNvPicPr>
@@ -12621,7 +13245,7 @@
       </p:pic>
       <p:sp>
         <p:nvSpPr>
-          <p:cNvPr id="8" name="Shape 5"/>
+          <p:cNvPr id="10" name="Shape 7"/>
           <p:cNvSpPr/>
           <p:nvPr/>
         </p:nvSpPr>
@@ -12648,7 +13272,7 @@
       </p:sp>
       <p:sp>
         <p:nvSpPr>
-          <p:cNvPr id="9" name="Text 6"/>
+          <p:cNvPr id="11" name="Text 8"/>
           <p:cNvSpPr txBox="1"/>
           <p:nvPr/>
         </p:nvSpPr>
@@ -12687,14 +13311,14 @@
       </p:sp>
       <p:sp>
         <p:nvSpPr>
-          <p:cNvPr id="10" name="Text 7"/>
+          <p:cNvPr id="12" name="Text 9"/>
           <p:cNvSpPr txBox="1"/>
           <p:nvPr/>
         </p:nvSpPr>
         <p:spPr>
           <a:xfrm>
             <a:off x="2651760" y="2377440"/>
-            <a:ext cx="2834640" cy="329184"/>
+            <a:ext cx="2697480" cy="329184"/>
           </a:xfrm>
           <a:prstGeom prst="rect">
             <a:avLst/>
@@ -12726,14 +13350,14 @@
       </p:sp>
       <p:sp>
         <p:nvSpPr>
-          <p:cNvPr id="11" name="Text 8"/>
-          <p:cNvSpPr txBox="1"/>
-          <p:nvPr/>
-        </p:nvSpPr>
-        <p:spPr>
-          <a:xfrm>
-            <a:off x="2651760" y="2761488"/>
-            <a:ext cx="4572000" cy="585216"/>
+          <p:cNvPr id="13" name="Text 10"/>
+          <p:cNvSpPr txBox="1"/>
+          <p:nvPr/>
+        </p:nvSpPr>
+        <p:spPr>
+          <a:xfrm>
+            <a:off x="2651760" y="2816352"/>
+            <a:ext cx="4572000" cy="566928"/>
           </a:xfrm>
           <a:prstGeom prst="rect">
             <a:avLst/>
@@ -12768,7 +13392,7 @@
       </p:sp>
       <p:sp>
         <p:nvSpPr>
-          <p:cNvPr id="12" name="Shape 9"/>
+          <p:cNvPr id="14" name="Shape 11"/>
           <p:cNvSpPr/>
           <p:nvPr/>
         </p:nvSpPr>
@@ -12795,7 +13419,7 @@
       </p:sp>
       <p:sp>
         <p:nvSpPr>
-          <p:cNvPr id="13" name="Text 10"/>
+          <p:cNvPr id="15" name="Text 12"/>
           <p:cNvSpPr txBox="1"/>
           <p:nvPr/>
         </p:nvSpPr>
@@ -12834,7 +13458,7 @@
       </p:sp>
       <p:sp>
         <p:nvSpPr>
-          <p:cNvPr id="14" name="Shape 11"/>
+          <p:cNvPr id="16" name="Shape 13"/>
           <p:cNvSpPr/>
           <p:nvPr/>
         </p:nvSpPr>
@@ -12859,7 +13483,7 @@
       </p:sp>
       <p:pic>
         <p:nvPicPr>
-          <p:cNvPr id="15" name="Image 1" descr="preencoded.png">    </p:cNvPr>
+          <p:cNvPr id="17" name="Image 1" descr="preencoded.png">    </p:cNvPr>
           <p:cNvPicPr>
             <a:picLocks noChangeAspect="1"/>
           </p:cNvPicPr>
@@ -12883,7 +13507,7 @@
       </p:pic>
       <p:sp>
         <p:nvSpPr>
-          <p:cNvPr id="16" name="Shape 12"/>
+          <p:cNvPr id="18" name="Shape 14"/>
           <p:cNvSpPr/>
           <p:nvPr/>
         </p:nvSpPr>
@@ -12910,7 +13534,7 @@
       </p:sp>
       <p:sp>
         <p:nvSpPr>
-          <p:cNvPr id="17" name="Text 13"/>
+          <p:cNvPr id="19" name="Text 15"/>
           <p:cNvSpPr txBox="1"/>
           <p:nvPr/>
         </p:nvSpPr>
@@ -12949,14 +13573,14 @@
       </p:sp>
       <p:sp>
         <p:nvSpPr>
-          <p:cNvPr id="18" name="Text 14"/>
+          <p:cNvPr id="20" name="Text 16"/>
           <p:cNvSpPr txBox="1"/>
           <p:nvPr/>
         </p:nvSpPr>
         <p:spPr>
           <a:xfrm>
             <a:off x="2651760" y="3602736"/>
-            <a:ext cx="2834640" cy="329184"/>
+            <a:ext cx="2697480" cy="329184"/>
           </a:xfrm>
           <a:prstGeom prst="rect">
             <a:avLst/>
@@ -12988,14 +13612,14 @@
       </p:sp>
       <p:sp>
         <p:nvSpPr>
-          <p:cNvPr id="19" name="Text 15"/>
-          <p:cNvSpPr txBox="1"/>
-          <p:nvPr/>
-        </p:nvSpPr>
-        <p:spPr>
-          <a:xfrm>
-            <a:off x="2651760" y="3986784"/>
-            <a:ext cx="4572000" cy="585216"/>
+          <p:cNvPr id="21" name="Text 17"/>
+          <p:cNvSpPr txBox="1"/>
+          <p:nvPr/>
+        </p:nvSpPr>
+        <p:spPr>
+          <a:xfrm>
+            <a:off x="2651760" y="4041648"/>
+            <a:ext cx="4572000" cy="566928"/>
           </a:xfrm>
           <a:prstGeom prst="rect">
             <a:avLst/>
@@ -13030,7 +13654,7 @@
       </p:sp>
       <p:sp>
         <p:nvSpPr>
-          <p:cNvPr id="20" name="Shape 16"/>
+          <p:cNvPr id="22" name="Shape 18"/>
           <p:cNvSpPr/>
           <p:nvPr/>
         </p:nvSpPr>
@@ -13057,7 +13681,7 @@
       </p:sp>
       <p:sp>
         <p:nvSpPr>
-          <p:cNvPr id="21" name="Text 17"/>
+          <p:cNvPr id="23" name="Text 19"/>
           <p:cNvSpPr txBox="1"/>
           <p:nvPr/>
         </p:nvSpPr>
@@ -13096,7 +13720,7 @@
       </p:sp>
       <p:sp>
         <p:nvSpPr>
-          <p:cNvPr id="22" name="Shape 18"/>
+          <p:cNvPr id="24" name="Shape 20"/>
           <p:cNvSpPr/>
           <p:nvPr/>
         </p:nvSpPr>
@@ -13121,7 +13745,7 @@
       </p:sp>
       <p:pic>
         <p:nvPicPr>
-          <p:cNvPr id="23" name="Image 2" descr="preencoded.png">    </p:cNvPr>
+          <p:cNvPr id="25" name="Image 2" descr="preencoded.png">    </p:cNvPr>
           <p:cNvPicPr>
             <a:picLocks noChangeAspect="1"/>
           </p:cNvPicPr>
@@ -13145,7 +13769,7 @@
       </p:pic>
       <p:sp>
         <p:nvSpPr>
-          <p:cNvPr id="24" name="Shape 19"/>
+          <p:cNvPr id="26" name="Shape 21"/>
           <p:cNvSpPr/>
           <p:nvPr/>
         </p:nvSpPr>
@@ -13172,7 +13796,7 @@
       </p:sp>
       <p:sp>
         <p:nvSpPr>
-          <p:cNvPr id="25" name="Text 20"/>
+          <p:cNvPr id="27" name="Text 22"/>
           <p:cNvSpPr txBox="1"/>
           <p:nvPr/>
         </p:nvSpPr>
@@ -13211,14 +13835,14 @@
       </p:sp>
       <p:sp>
         <p:nvSpPr>
-          <p:cNvPr id="26" name="Text 21"/>
+          <p:cNvPr id="28" name="Text 23"/>
           <p:cNvSpPr txBox="1"/>
           <p:nvPr/>
         </p:nvSpPr>
         <p:spPr>
           <a:xfrm>
             <a:off x="2651760" y="4828032"/>
-            <a:ext cx="2834640" cy="329184"/>
+            <a:ext cx="2697480" cy="329184"/>
           </a:xfrm>
           <a:prstGeom prst="rect">
             <a:avLst/>
@@ -13250,14 +13874,14 @@
       </p:sp>
       <p:sp>
         <p:nvSpPr>
-          <p:cNvPr id="27" name="Text 22"/>
-          <p:cNvSpPr txBox="1"/>
-          <p:nvPr/>
-        </p:nvSpPr>
-        <p:spPr>
-          <a:xfrm>
-            <a:off x="2651760" y="5212080"/>
-            <a:ext cx="4572000" cy="585216"/>
+          <p:cNvPr id="29" name="Text 24"/>
+          <p:cNvSpPr txBox="1"/>
+          <p:nvPr/>
+        </p:nvSpPr>
+        <p:spPr>
+          <a:xfrm>
+            <a:off x="2651760" y="5266944"/>
+            <a:ext cx="4572000" cy="566928"/>
           </a:xfrm>
           <a:prstGeom prst="rect">
             <a:avLst/>
@@ -13292,7 +13916,7 @@
       </p:sp>
       <p:sp>
         <p:nvSpPr>
-          <p:cNvPr id="28" name="Shape 23"/>
+          <p:cNvPr id="30" name="Shape 25"/>
           <p:cNvSpPr/>
           <p:nvPr/>
         </p:nvSpPr>
@@ -13319,7 +13943,7 @@
       </p:sp>
       <p:sp>
         <p:nvSpPr>
-          <p:cNvPr id="29" name="Text 24"/>
+          <p:cNvPr id="31" name="Text 26"/>
           <p:cNvSpPr txBox="1"/>
           <p:nvPr/>
         </p:nvSpPr>
@@ -13358,18 +13982,18 @@
       </p:sp>
       <p:sp>
         <p:nvSpPr>
-          <p:cNvPr id="30" name="Shape 25"/>
+          <p:cNvPr id="32" name="Shape 27"/>
           <p:cNvSpPr/>
           <p:nvPr/>
         </p:nvSpPr>
         <p:spPr>
           <a:xfrm>
             <a:off x="7589520" y="2395728"/>
-            <a:ext cx="3959352" cy="3429000"/>
+            <a:ext cx="3959352" cy="3474720"/>
           </a:xfrm>
           <a:prstGeom prst="roundRect">
             <a:avLst>
-              <a:gd name="adj" fmla="val 3733"/>
+              <a:gd name="adj" fmla="val 3684"/>
             </a:avLst>
           </a:prstGeom>
           <a:solidFill>
@@ -13385,7 +14009,7 @@
       </p:sp>
       <p:sp>
         <p:nvSpPr>
-          <p:cNvPr id="31" name="Text 26"/>
+          <p:cNvPr id="33" name="Text 28"/>
           <p:cNvSpPr txBox="1"/>
           <p:nvPr/>
         </p:nvSpPr>
@@ -13438,7 +14062,7 @@
       </p:sp>
       <p:sp>
         <p:nvSpPr>
-          <p:cNvPr id="32" name="Shape 27"/>
+          <p:cNvPr id="34" name="Shape 29"/>
           <p:cNvSpPr/>
           <p:nvPr/>
         </p:nvSpPr>
@@ -13465,7 +14089,7 @@
       </p:sp>
       <p:sp>
         <p:nvSpPr>
-          <p:cNvPr id="33" name="Text 28"/>
+          <p:cNvPr id="35" name="Text 30"/>
           <p:cNvSpPr txBox="1"/>
           <p:nvPr/>
         </p:nvSpPr>
@@ -13504,7 +14128,7 @@
       </p:sp>
       <p:sp>
         <p:nvSpPr>
-          <p:cNvPr id="34" name="Text 29"/>
+          <p:cNvPr id="36" name="Text 31"/>
           <p:cNvSpPr txBox="1"/>
           <p:nvPr/>
         </p:nvSpPr>
@@ -13543,7 +14167,7 @@
       </p:sp>
       <p:sp>
         <p:nvSpPr>
-          <p:cNvPr id="35" name="Text 30"/>
+          <p:cNvPr id="37" name="Text 32"/>
           <p:cNvSpPr txBox="1"/>
           <p:nvPr/>
         </p:nvSpPr>
@@ -13582,13 +14206,13 @@
       </p:sp>
       <p:sp>
         <p:nvSpPr>
-          <p:cNvPr id="36" name="Text 31"/>
-          <p:cNvSpPr txBox="1"/>
-          <p:nvPr/>
-        </p:nvSpPr>
-        <p:spPr>
-          <a:xfrm>
-            <a:off x="7882128" y="3694176"/>
+          <p:cNvPr id="38" name="Text 33"/>
+          <p:cNvSpPr txBox="1"/>
+          <p:nvPr/>
+        </p:nvSpPr>
+        <p:spPr>
+          <a:xfrm>
+            <a:off x="7882128" y="3749040"/>
             <a:ext cx="3383280" cy="219456"/>
           </a:xfrm>
           <a:prstGeom prst="rect">
@@ -13621,14 +14245,14 @@
       </p:sp>
       <p:sp>
         <p:nvSpPr>
-          <p:cNvPr id="37" name="Shape 32"/>
+          <p:cNvPr id="39" name="Shape 34"/>
           <p:cNvSpPr/>
           <p:nvPr/>
         </p:nvSpPr>
         <p:spPr>
           <a:xfrm>
-            <a:off x="7882128" y="4023360"/>
-            <a:ext cx="1097280" cy="310896"/>
+            <a:off x="7882128" y="3968496"/>
+            <a:ext cx="1042416" cy="310896"/>
           </a:xfrm>
           <a:prstGeom prst="roundRect">
             <a:avLst>
@@ -13648,14 +14272,14 @@
       </p:sp>
       <p:sp>
         <p:nvSpPr>
-          <p:cNvPr id="38" name="Text 33"/>
-          <p:cNvSpPr txBox="1"/>
-          <p:nvPr/>
-        </p:nvSpPr>
-        <p:spPr>
-          <a:xfrm>
-            <a:off x="7882128" y="4005072"/>
-            <a:ext cx="1097280" cy="310896"/>
+          <p:cNvPr id="40" name="Text 35"/>
+          <p:cNvSpPr txBox="1"/>
+          <p:nvPr/>
+        </p:nvSpPr>
+        <p:spPr>
+          <a:xfrm>
+            <a:off x="7882128" y="3950208"/>
+            <a:ext cx="1042416" cy="310896"/>
           </a:xfrm>
           <a:prstGeom prst="rect">
             <a:avLst/>
@@ -13687,14 +14311,14 @@
       </p:sp>
       <p:sp>
         <p:nvSpPr>
-          <p:cNvPr id="39" name="Shape 34"/>
+          <p:cNvPr id="41" name="Shape 36"/>
           <p:cNvSpPr/>
           <p:nvPr/>
         </p:nvSpPr>
         <p:spPr>
           <a:xfrm>
-            <a:off x="9025128" y="4023360"/>
-            <a:ext cx="1097280" cy="310896"/>
+            <a:off x="9052560" y="3968496"/>
+            <a:ext cx="1042416" cy="310896"/>
           </a:xfrm>
           <a:prstGeom prst="roundRect">
             <a:avLst>
@@ -13714,14 +14338,14 @@
       </p:sp>
       <p:sp>
         <p:nvSpPr>
-          <p:cNvPr id="40" name="Text 35"/>
-          <p:cNvSpPr txBox="1"/>
-          <p:nvPr/>
-        </p:nvSpPr>
-        <p:spPr>
-          <a:xfrm>
-            <a:off x="9025128" y="4005072"/>
-            <a:ext cx="1097280" cy="310896"/>
+          <p:cNvPr id="42" name="Text 37"/>
+          <p:cNvSpPr txBox="1"/>
+          <p:nvPr/>
+        </p:nvSpPr>
+        <p:spPr>
+          <a:xfrm>
+            <a:off x="9052560" y="3950208"/>
+            <a:ext cx="1042416" cy="310896"/>
           </a:xfrm>
           <a:prstGeom prst="rect">
             <a:avLst/>
@@ -13753,14 +14377,14 @@
       </p:sp>
       <p:sp>
         <p:nvSpPr>
-          <p:cNvPr id="41" name="Shape 36"/>
+          <p:cNvPr id="43" name="Shape 38"/>
           <p:cNvSpPr/>
           <p:nvPr/>
         </p:nvSpPr>
         <p:spPr>
           <a:xfrm>
-            <a:off x="10168128" y="4023360"/>
-            <a:ext cx="1097280" cy="310896"/>
+            <a:off x="10222992" y="3968496"/>
+            <a:ext cx="1042416" cy="310896"/>
           </a:xfrm>
           <a:prstGeom prst="roundRect">
             <a:avLst>
@@ -13780,14 +14404,14 @@
       </p:sp>
       <p:sp>
         <p:nvSpPr>
-          <p:cNvPr id="42" name="Text 37"/>
-          <p:cNvSpPr txBox="1"/>
-          <p:nvPr/>
-        </p:nvSpPr>
-        <p:spPr>
-          <a:xfrm>
-            <a:off x="10168128" y="4005072"/>
-            <a:ext cx="1097280" cy="310896"/>
+          <p:cNvPr id="44" name="Text 39"/>
+          <p:cNvSpPr txBox="1"/>
+          <p:nvPr/>
+        </p:nvSpPr>
+        <p:spPr>
+          <a:xfrm>
+            <a:off x="10222992" y="3950208"/>
+            <a:ext cx="1042416" cy="310896"/>
           </a:xfrm>
           <a:prstGeom prst="rect">
             <a:avLst/>
@@ -13819,13 +14443,13 @@
       </p:sp>
       <p:sp>
         <p:nvSpPr>
-          <p:cNvPr id="43" name="Text 38"/>
-          <p:cNvSpPr txBox="1"/>
-          <p:nvPr/>
-        </p:nvSpPr>
-        <p:spPr>
-          <a:xfrm>
-            <a:off x="7882128" y="4498848"/>
+          <p:cNvPr id="45" name="Text 40"/>
+          <p:cNvSpPr txBox="1"/>
+          <p:nvPr/>
+        </p:nvSpPr>
+        <p:spPr>
+          <a:xfrm>
+            <a:off x="7882128" y="4443984"/>
             <a:ext cx="3383280" cy="457200"/>
           </a:xfrm>
           <a:prstGeom prst="rect">
@@ -13915,13 +14539,13 @@
       </p:sp>
       <p:sp>
         <p:nvSpPr>
-          <p:cNvPr id="44" name="Shape 39"/>
+          <p:cNvPr id="46" name="Shape 41"/>
           <p:cNvSpPr/>
           <p:nvPr/>
         </p:nvSpPr>
         <p:spPr>
           <a:xfrm>
-            <a:off x="7882128" y="5047488"/>
+            <a:off x="7882128" y="4992624"/>
             <a:ext cx="3383280" cy="420624"/>
           </a:xfrm>
           <a:prstGeom prst="roundRect">
@@ -13942,13 +14566,13 @@
       </p:sp>
       <p:sp>
         <p:nvSpPr>
-          <p:cNvPr id="45" name="Text 40"/>
-          <p:cNvSpPr txBox="1"/>
-          <p:nvPr/>
-        </p:nvSpPr>
-        <p:spPr>
-          <a:xfrm>
-            <a:off x="7882128" y="5029200"/>
+          <p:cNvPr id="47" name="Text 42"/>
+          <p:cNvSpPr txBox="1"/>
+          <p:nvPr/>
+        </p:nvSpPr>
+        <p:spPr>
+          <a:xfrm>
+            <a:off x="7882128" y="4974336"/>
             <a:ext cx="3383280" cy="420624"/>
           </a:xfrm>
           <a:prstGeom prst="rect">
@@ -13981,13 +14605,13 @@
       </p:sp>
       <p:sp>
         <p:nvSpPr>
-          <p:cNvPr id="46" name="Text 41"/>
-          <p:cNvSpPr txBox="1"/>
-          <p:nvPr/>
-        </p:nvSpPr>
-        <p:spPr>
-          <a:xfrm>
-            <a:off x="7882128" y="5559552"/>
+          <p:cNvPr id="48" name="Text 43"/>
+          <p:cNvSpPr txBox="1"/>
+          <p:nvPr/>
+        </p:nvSpPr>
+        <p:spPr>
+          <a:xfrm>
+            <a:off x="7882128" y="5504688"/>
             <a:ext cx="3383280" cy="219456"/>
           </a:xfrm>
           <a:prstGeom prst="rect">
@@ -14020,13 +14644,13 @@
       </p:sp>
       <p:sp>
         <p:nvSpPr>
-          <p:cNvPr id="47" name="Text 42"/>
-          <p:cNvSpPr txBox="1"/>
-          <p:nvPr/>
-        </p:nvSpPr>
-        <p:spPr>
-          <a:xfrm>
-            <a:off x="7589520" y="5888736"/>
+          <p:cNvPr id="49" name="Text 44"/>
+          <p:cNvSpPr txBox="1"/>
+          <p:nvPr/>
+        </p:nvSpPr>
+        <p:spPr>
+          <a:xfrm>
+            <a:off x="7589520" y="5961888"/>
             <a:ext cx="3959352" cy="256032"/>
           </a:xfrm>
           <a:prstGeom prst="rect">

</xml_diff>